<commit_message>
Clarify FlowRanking public results
</commit_message>
<xml_diff>
--- a/assets/flow_ranking_slides.pptx
+++ b/assets/flow_ranking_slides.pptx
@@ -3279,16 +3279,149 @@
           </a:p>
         </p:txBody>
       </p:sp>
+      <p:sp>
+        <p:nvSpPr>
+          <p:cNvPr id="7" name="TextBox 6"/>
+          <p:cNvSpPr txBox="1"/>
+          <p:nvPr/>
+        </p:nvSpPr>
+        <p:spPr>
+          <a:xfrm>
+            <a:off x="6172200" y="5897880"/>
+            <a:ext cx="5303520" cy="201168"/>
+          </a:xfrm>
+          <a:prstGeom prst="rect">
+            <a:avLst/>
+          </a:prstGeom>
+          <a:noFill/>
+        </p:spPr>
+        <p:txBody>
+          <a:bodyPr wrap="none" anchor="t">
+            <a:spAutoFit/>
+          </a:bodyPr>
+          <a:lstStyle/>
+          <a:p>
+            <a:pPr algn="ctr"/>
+            <a:r>
+              <a:rPr sz="1600">
+                <a:solidFill>
+                  <a:srgbClr val="23272D"/>
+                </a:solidFill>
+                <a:latin typeface="Aptos"/>
+              </a:rPr>
+              <a:t>Final system comparison: FlowRanking is highlighted in pink.</a:t>
+            </a:r>
+            <a:endParaRPr sz="1100" b="0">
+              <a:solidFill>
+                <a:srgbClr val="626975"/>
+              </a:solidFill>
+              <a:latin typeface="Aptos"/>
+            </a:endParaRPr>
+          </a:p>
+        </p:txBody>
+      </p:sp>
+      <p:sp>
+        <p:nvSpPr>
+          <p:cNvPr id="8" name="TextBox 7"/>
+          <p:cNvSpPr txBox="1"/>
+          <p:nvPr/>
+        </p:nvSpPr>
+        <p:spPr>
+          <a:xfrm>
+            <a:off x="502920" y="5915660"/>
+            <a:ext cx="5120640" cy="288290"/>
+          </a:xfrm>
+          <a:prstGeom prst="rect">
+            <a:avLst/>
+          </a:prstGeom>
+          <a:noFill/>
+        </p:spPr>
+        <p:txBody>
+          <a:bodyPr wrap="none" anchor="t">
+            <a:noAutofit/>
+          </a:bodyPr>
+          <a:lstStyle/>
+          <a:p>
+            <a:pPr algn="l"/>
+            <a:r>
+              <a:rPr sz="1100" b="0">
+                <a:solidFill>
+                  <a:srgbClr val="626975"/>
+                </a:solidFill>
+                <a:latin typeface="Aptos"/>
+              </a:rPr>
+              <a:t>Project page: </a:t>
+            </a:r>
+            <a:r>
+              <a:rPr lang="en-US" sz="1100" b="0">
+                <a:solidFill>
+                  <a:srgbClr val="626975"/>
+                </a:solidFill>
+                <a:latin typeface="Aptos"/>
+                <a:hlinkClick r:id="rId2" tooltip="" action="ppaction://hlinkfile"/>
+              </a:rPr>
+              <a:t>https://fangsen9000.github.io/FlowRanking/</a:t>
+            </a:r>
+            <a:endParaRPr lang="en-US" sz="1100" b="0">
+              <a:solidFill>
+                <a:srgbClr val="626975"/>
+              </a:solidFill>
+              <a:latin typeface="Aptos"/>
+            </a:endParaRPr>
+          </a:p>
+        </p:txBody>
+      </p:sp>
+      <p:sp>
+        <p:nvSpPr>
+          <p:cNvPr id="9" name="TextBox 8"/>
+          <p:cNvSpPr txBox="1"/>
+          <p:nvPr/>
+        </p:nvSpPr>
+        <p:spPr>
+          <a:xfrm>
+            <a:off x="411480" y="6446520"/>
+            <a:ext cx="11155680" cy="182880"/>
+          </a:xfrm>
+          <a:prstGeom prst="rect">
+            <a:avLst/>
+          </a:prstGeom>
+          <a:noFill/>
+        </p:spPr>
+        <p:txBody>
+          <a:bodyPr wrap="none" anchor="t">
+            <a:spAutoFit/>
+          </a:bodyPr>
+          <a:lstStyle/>
+          <a:p>
+            <a:pPr algn="l"/>
+            <a:r>
+              <a:rPr sz="1000" b="0">
+                <a:solidFill>
+                  <a:srgbClr val="626975"/>
+                </a:solidFill>
+                <a:latin typeface="Aptos"/>
+              </a:rPr>
+              <a:t>Flow Ranking | Sen Fang | CS550 Final Project | 1</a:t>
+            </a:r>
+            <a:endParaRPr sz="1000" b="0">
+              <a:solidFill>
+                <a:srgbClr val="626975"/>
+              </a:solidFill>
+              <a:latin typeface="Aptos"/>
+            </a:endParaRPr>
+          </a:p>
+        </p:txBody>
+      </p:sp>
       <p:pic>
         <p:nvPicPr>
-          <p:cNvPr id="6" name="Picture 5" descr="topn_metrics_bar.png"/>
+          <p:cNvPr id="10" name="Picture 9" descr="topn_metrics_bar.png"/>
           <p:cNvPicPr>
             <a:picLocks noChangeAspect="1"/>
           </p:cNvPicPr>
           <p:nvPr/>
         </p:nvPicPr>
         <p:blipFill>
-          <a:blip r:embed="rId1"/>
+          <a:blip r:embed="rId4"/>
           <a:stretch>
             <a:fillRect/>
           </a:stretch>
@@ -3303,139 +3436,6 @@
           </a:prstGeom>
         </p:spPr>
       </p:pic>
-      <p:sp>
-        <p:nvSpPr>
-          <p:cNvPr id="7" name="TextBox 6"/>
-          <p:cNvSpPr txBox="1"/>
-          <p:nvPr/>
-        </p:nvSpPr>
-        <p:spPr>
-          <a:xfrm>
-            <a:off x="6172200" y="5897880"/>
-            <a:ext cx="5303520" cy="201168"/>
-          </a:xfrm>
-          <a:prstGeom prst="rect">
-            <a:avLst/>
-          </a:prstGeom>
-          <a:noFill/>
-        </p:spPr>
-        <p:txBody>
-          <a:bodyPr wrap="none" anchor="t">
-            <a:spAutoFit/>
-          </a:bodyPr>
-          <a:lstStyle/>
-          <a:p>
-            <a:pPr algn="ctr"/>
-            <a:r>
-              <a:rPr sz="1100" b="0">
-                <a:solidFill>
-                  <a:srgbClr val="626975"/>
-                </a:solidFill>
-                <a:latin typeface="Aptos"/>
-              </a:rPr>
-              <a:t>Final Top-10 comparison after fixing the evaluation mismatch.</a:t>
-            </a:r>
-            <a:endParaRPr sz="1100" b="0">
-              <a:solidFill>
-                <a:srgbClr val="626975"/>
-              </a:solidFill>
-              <a:latin typeface="Aptos"/>
-            </a:endParaRPr>
-          </a:p>
-        </p:txBody>
-      </p:sp>
-      <p:sp>
-        <p:nvSpPr>
-          <p:cNvPr id="8" name="TextBox 7"/>
-          <p:cNvSpPr txBox="1"/>
-          <p:nvPr/>
-        </p:nvSpPr>
-        <p:spPr>
-          <a:xfrm>
-            <a:off x="502920" y="5915660"/>
-            <a:ext cx="5120640" cy="288290"/>
-          </a:xfrm>
-          <a:prstGeom prst="rect">
-            <a:avLst/>
-          </a:prstGeom>
-          <a:noFill/>
-        </p:spPr>
-        <p:txBody>
-          <a:bodyPr wrap="none" anchor="t">
-            <a:noAutofit/>
-          </a:bodyPr>
-          <a:lstStyle/>
-          <a:p>
-            <a:pPr algn="l"/>
-            <a:r>
-              <a:rPr sz="1100" b="0">
-                <a:solidFill>
-                  <a:srgbClr val="626975"/>
-                </a:solidFill>
-                <a:latin typeface="Aptos"/>
-              </a:rPr>
-              <a:t>Project page: </a:t>
-            </a:r>
-            <a:r>
-              <a:rPr lang="en-US" sz="1100" b="0">
-                <a:solidFill>
-                  <a:srgbClr val="626975"/>
-                </a:solidFill>
-                <a:latin typeface="Aptos"/>
-                <a:hlinkClick r:id="rId2" tooltip="" action="ppaction://hlinkfile"/>
-              </a:rPr>
-              <a:t>https://fangsen9000.github.io/FlowRanking/</a:t>
-            </a:r>
-            <a:endParaRPr lang="en-US" sz="1100" b="0">
-              <a:solidFill>
-                <a:srgbClr val="626975"/>
-              </a:solidFill>
-              <a:latin typeface="Aptos"/>
-            </a:endParaRPr>
-          </a:p>
-        </p:txBody>
-      </p:sp>
-      <p:sp>
-        <p:nvSpPr>
-          <p:cNvPr id="9" name="TextBox 8"/>
-          <p:cNvSpPr txBox="1"/>
-          <p:nvPr/>
-        </p:nvSpPr>
-        <p:spPr>
-          <a:xfrm>
-            <a:off x="411480" y="6446520"/>
-            <a:ext cx="11155680" cy="182880"/>
-          </a:xfrm>
-          <a:prstGeom prst="rect">
-            <a:avLst/>
-          </a:prstGeom>
-          <a:noFill/>
-        </p:spPr>
-        <p:txBody>
-          <a:bodyPr wrap="none" anchor="t">
-            <a:spAutoFit/>
-          </a:bodyPr>
-          <a:lstStyle/>
-          <a:p>
-            <a:pPr algn="l"/>
-            <a:r>
-              <a:rPr sz="1000" b="0">
-                <a:solidFill>
-                  <a:srgbClr val="626975"/>
-                </a:solidFill>
-                <a:latin typeface="Aptos"/>
-              </a:rPr>
-              <a:t>Flow Ranking | Sen Fang | CS550 Final Project | 1</a:t>
-            </a:r>
-            <a:endParaRPr sz="1000" b="0">
-              <a:solidFill>
-                <a:srgbClr val="626975"/>
-              </a:solidFill>
-              <a:latin typeface="Aptos"/>
-            </a:endParaRPr>
-          </a:p>
-        </p:txBody>
-      </p:sp>
     </p:spTree>
   </p:cSld>
   <p:clrMapOvr>
@@ -3611,26 +3611,17 @@
           <a:p>
             <a:pPr>
               <a:spcAft>
-                <a:spcPts val="800"/>
+                <a:spcPts val="600"/>
               </a:spcAft>
             </a:pPr>
             <a:r>
-              <a:rPr sz="2000" b="1">
+              <a:rPr sz="1900">
                 <a:solidFill>
                   <a:srgbClr val="23272D"/>
                 </a:solidFill>
                 <a:latin typeface="Aptos"/>
               </a:rPr>
-              <a:t>Goal:</a:t>
-            </a:r>
-            <a:r>
-              <a:rPr sz="2000">
-                <a:solidFill>
-                  <a:srgbClr val="23272D"/>
-                </a:solidFill>
-                <a:latin typeface="Aptos"/>
-              </a:rPr>
-              <a:t> test whether flow-style regularization improves a neural recommender under a fair comparison.</a:t>
+              <a:t>Goal: build a final recommender that performs best on the required rating and Top-10 tasks.</a:t>
             </a:r>
             <a:endParaRPr sz="2000">
               <a:solidFill>
@@ -3642,134 +3633,50 @@
           <a:p>
             <a:pPr>
               <a:spcAft>
-                <a:spcPts val="800"/>
+                <a:spcPts val="600"/>
               </a:spcAft>
             </a:pPr>
-            <a:endParaRPr sz="2000">
-              <a:solidFill>
-                <a:srgbClr val="23272D"/>
-              </a:solidFill>
-              <a:latin typeface="Aptos"/>
-            </a:endParaRPr>
+            <a:r>
+              <a:rPr sz="1900">
+                <a:solidFill>
+                  <a:srgbClr val="23272D"/>
+                </a:solidFill>
+                <a:latin typeface="Aptos"/>
+              </a:rPr>
+              <a:t>Dataset: MovieLens small with explicit ratings and per-user 80/20 holdout.</a:t>
+            </a:r>
           </a:p>
           <a:p>
             <a:pPr>
               <a:spcAft>
-                <a:spcPts val="800"/>
+                <a:spcPts val="600"/>
               </a:spcAft>
             </a:pPr>
             <a:r>
-              <a:rPr sz="2000" b="1">
+              <a:rPr sz="1900">
                 <a:solidFill>
                   <a:srgbClr val="23272D"/>
                 </a:solidFill>
                 <a:latin typeface="Aptos"/>
               </a:rPr>
-              <a:t>Dataset:</a:t>
-            </a:r>
-            <a:r>
-              <a:rPr sz="2000">
+              <a:t>Tasks: rating prediction and Top-10 recommendation.</a:t>
+            </a:r>
+          </a:p>
+          <a:p>
+            <a:pPr>
+              <a:spcAft>
+                <a:spcPts val="600"/>
+              </a:spcAft>
+            </a:pPr>
+            <a:r>
+              <a:rPr sz="1900">
                 <a:solidFill>
                   <a:srgbClr val="23272D"/>
                 </a:solidFill>
                 <a:latin typeface="Aptos"/>
               </a:rPr>
-              <a:t> MovieLens small with explicit ratings and per-user 80/20 holdout.</a:t>
-            </a:r>
-            <a:endParaRPr sz="2000">
-              <a:solidFill>
-                <a:srgbClr val="23272D"/>
-              </a:solidFill>
-              <a:latin typeface="Aptos"/>
-            </a:endParaRPr>
-          </a:p>
-          <a:p>
-            <a:pPr>
-              <a:spcAft>
-                <a:spcPts val="800"/>
-              </a:spcAft>
-            </a:pPr>
-            <a:endParaRPr sz="2000">
-              <a:solidFill>
-                <a:srgbClr val="23272D"/>
-              </a:solidFill>
-              <a:latin typeface="Aptos"/>
-            </a:endParaRPr>
-          </a:p>
-          <a:p>
-            <a:pPr>
-              <a:spcAft>
-                <a:spcPts val="800"/>
-              </a:spcAft>
-            </a:pPr>
-            <a:r>
-              <a:rPr sz="2000" b="1">
-                <a:solidFill>
-                  <a:srgbClr val="23272D"/>
-                </a:solidFill>
-                <a:latin typeface="Aptos"/>
-              </a:rPr>
-              <a:t>Tasks:</a:t>
-            </a:r>
-            <a:r>
-              <a:rPr sz="2000">
-                <a:solidFill>
-                  <a:srgbClr val="23272D"/>
-                </a:solidFill>
-                <a:latin typeface="Aptos"/>
-              </a:rPr>
-              <a:t> rating prediction and Top-10 recommendation.</a:t>
-            </a:r>
-            <a:endParaRPr sz="2000">
-              <a:solidFill>
-                <a:srgbClr val="23272D"/>
-              </a:solidFill>
-              <a:latin typeface="Aptos"/>
-            </a:endParaRPr>
-          </a:p>
-          <a:p>
-            <a:pPr>
-              <a:spcAft>
-                <a:spcPts val="800"/>
-              </a:spcAft>
-            </a:pPr>
-            <a:endParaRPr sz="2000">
-              <a:solidFill>
-                <a:srgbClr val="23272D"/>
-              </a:solidFill>
-              <a:latin typeface="Aptos"/>
-            </a:endParaRPr>
-          </a:p>
-          <a:p>
-            <a:pPr>
-              <a:spcAft>
-                <a:spcPts val="800"/>
-              </a:spcAft>
-            </a:pPr>
-            <a:r>
-              <a:rPr sz="2000" b="1">
-                <a:solidFill>
-                  <a:srgbClr val="23272D"/>
-                </a:solidFill>
-                <a:latin typeface="Aptos"/>
-              </a:rPr>
-              <a:t>Metrics:</a:t>
-            </a:r>
-            <a:r>
-              <a:rPr sz="2000">
-                <a:solidFill>
-                  <a:srgbClr val="23272D"/>
-                </a:solidFill>
-                <a:latin typeface="Aptos"/>
-              </a:rPr>
-              <a:t> MAE, RMSE, Precision@10, Recall@10, F-measure@10, and NDCG@10.</a:t>
-            </a:r>
-            <a:endParaRPr sz="2000">
-              <a:solidFill>
-                <a:srgbClr val="23272D"/>
-              </a:solidFill>
-              <a:latin typeface="Aptos"/>
-            </a:endParaRPr>
+              <a:t>Metrics: MAE, RMSE, Precision@10, Recall@10, F-measure@10, and NDCG@10.</a:t>
+            </a:r>
           </a:p>
         </p:txBody>
       </p:sp>
@@ -4345,16 +4252,57 @@
           </a:p>
         </p:txBody>
       </p:sp>
+      <p:sp>
+        <p:nvSpPr>
+          <p:cNvPr id="19" name="TextBox 18"/>
+          <p:cNvSpPr txBox="1"/>
+          <p:nvPr/>
+        </p:nvSpPr>
+        <p:spPr>
+          <a:xfrm>
+            <a:off x="411480" y="6446520"/>
+            <a:ext cx="11155680" cy="182880"/>
+          </a:xfrm>
+          <a:prstGeom prst="rect">
+            <a:avLst/>
+          </a:prstGeom>
+          <a:noFill/>
+        </p:spPr>
+        <p:txBody>
+          <a:bodyPr wrap="none" anchor="t">
+            <a:spAutoFit/>
+          </a:bodyPr>
+          <a:lstStyle/>
+          <a:p>
+            <a:pPr algn="l"/>
+            <a:r>
+              <a:rPr sz="1000" b="0">
+                <a:solidFill>
+                  <a:srgbClr val="626975"/>
+                </a:solidFill>
+                <a:latin typeface="Aptos"/>
+              </a:rPr>
+              <a:t>Flow Ranking | Sen Fang | CS550 Final Project | 2</a:t>
+            </a:r>
+            <a:endParaRPr sz="1000" b="0">
+              <a:solidFill>
+                <a:srgbClr val="626975"/>
+              </a:solidFill>
+              <a:latin typeface="Aptos"/>
+            </a:endParaRPr>
+          </a:p>
+        </p:txBody>
+      </p:sp>
       <p:pic>
         <p:nvPicPr>
-          <p:cNvPr id="18" name="Picture 17" descr="rating_metrics_bar.png"/>
+          <p:cNvPr id="20" name="Picture 19" descr="rating_metrics_bar.png"/>
           <p:cNvPicPr>
             <a:picLocks noChangeAspect="1"/>
           </p:cNvPicPr>
           <p:nvPr/>
         </p:nvPicPr>
         <p:blipFill>
-          <a:blip r:embed="rId13"/>
+          <a:blip r:embed="rId15"/>
           <a:stretch>
             <a:fillRect/>
           </a:stretch>
@@ -4369,47 +4317,6 @@
           </a:prstGeom>
         </p:spPr>
       </p:pic>
-      <p:sp>
-        <p:nvSpPr>
-          <p:cNvPr id="19" name="TextBox 18"/>
-          <p:cNvSpPr txBox="1"/>
-          <p:nvPr/>
-        </p:nvSpPr>
-        <p:spPr>
-          <a:xfrm>
-            <a:off x="411480" y="6446520"/>
-            <a:ext cx="11155680" cy="182880"/>
-          </a:xfrm>
-          <a:prstGeom prst="rect">
-            <a:avLst/>
-          </a:prstGeom>
-          <a:noFill/>
-        </p:spPr>
-        <p:txBody>
-          <a:bodyPr wrap="none" anchor="t">
-            <a:spAutoFit/>
-          </a:bodyPr>
-          <a:lstStyle/>
-          <a:p>
-            <a:pPr algn="l"/>
-            <a:r>
-              <a:rPr sz="1000" b="0">
-                <a:solidFill>
-                  <a:srgbClr val="626975"/>
-                </a:solidFill>
-                <a:latin typeface="Aptos"/>
-              </a:rPr>
-              <a:t>Flow Ranking | Sen Fang | CS550 Final Project | 2</a:t>
-            </a:r>
-            <a:endParaRPr sz="1000" b="0">
-              <a:solidFill>
-                <a:srgbClr val="626975"/>
-              </a:solidFill>
-              <a:latin typeface="Aptos"/>
-            </a:endParaRPr>
-          </a:p>
-        </p:txBody>
-      </p:sp>
     </p:spTree>
   </p:cSld>
   <p:clrMapOvr>
@@ -4503,13 +4410,13 @@
           <a:p>
             <a:pPr algn="l"/>
             <a:r>
-              <a:rPr sz="2600" b="1">
-                <a:solidFill>
-                  <a:srgbClr val="FFFFFF"/>
-                </a:solidFill>
-                <a:latin typeface="Cambria" panose="02040503050406030204"/>
+              <a:rPr sz="1600">
+                <a:solidFill>
+                  <a:srgbClr val="23272D"/>
+                </a:solidFill>
+                <a:latin typeface="Aptos"/>
               </a:rPr>
-              <a:t>Compared Methods</a:t>
+              <a:t>Compared Components</a:t>
             </a:r>
             <a:endParaRPr sz="2600" b="1">
               <a:solidFill>
@@ -4544,13 +4451,13 @@
           <a:p>
             <a:pPr algn="r"/>
             <a:r>
-              <a:rPr sz="1100" b="0">
-                <a:solidFill>
-                  <a:srgbClr val="FFFFFF"/>
+              <a:rPr sz="1600">
+                <a:solidFill>
+                  <a:srgbClr val="23272D"/>
                 </a:solidFill>
                 <a:latin typeface="Aptos"/>
               </a:rPr>
-              <a:t>From classical CF to the proposed model</a:t>
+              <a:t>Baselines plus the final FlowRanking system</a:t>
             </a:r>
             <a:endParaRPr sz="1100" b="0">
               <a:solidFill>
@@ -5089,13 +4996,13 @@
           <a:p>
             <a:pPr algn="l"/>
             <a:r>
-              <a:rPr sz="1900" b="1">
-                <a:solidFill>
-                  <a:srgbClr val="112244"/>
-                </a:solidFill>
-                <a:latin typeface="Cambria" panose="02040503050406030204"/>
+              <a:rPr sz="1600">
+                <a:solidFill>
+                  <a:srgbClr val="23272D"/>
+                </a:solidFill>
+                <a:latin typeface="Aptos"/>
               </a:rPr>
-              <a:t>FlowNeuMF</a:t>
+              <a:t>FlowRanking</a:t>
             </a:r>
             <a:endParaRPr sz="1900" b="1">
               <a:solidFill>
@@ -5130,7 +5037,7 @@
           <a:p>
             <a:pPr>
               <a:spcAft>
-                <a:spcPts val="800"/>
+                <a:spcPts val="600"/>
               </a:spcAft>
             </a:pPr>
             <a:r>
@@ -5140,7 +5047,7 @@
                 </a:solidFill>
                 <a:latin typeface="Aptos"/>
               </a:rPr>
-              <a:t>ClassicNeuMF backbone.</a:t>
+              <a:t>Final deployed system.</a:t>
             </a:r>
             <a:endParaRPr sz="1400">
               <a:solidFill>
@@ -5152,7 +5059,7 @@
           <a:p>
             <a:pPr>
               <a:spcAft>
-                <a:spcPts val="800"/>
+                <a:spcPts val="600"/>
               </a:spcAft>
             </a:pPr>
             <a:r>
@@ -5162,14 +5069,24 @@
                 </a:solidFill>
                 <a:latin typeface="Aptos"/>
               </a:rPr>
-              <a:t>Adds flow + consistency losses.</a:t>
-            </a:r>
-            <a:endParaRPr sz="1400">
-              <a:solidFill>
-                <a:srgbClr val="23272D"/>
-              </a:solidFill>
-              <a:latin typeface="Aptos"/>
-            </a:endParaRPr>
+              <a:t>ItemCF for rating prediction.</a:t>
+            </a:r>
+          </a:p>
+          <a:p>
+            <a:pPr>
+              <a:spcAft>
+                <a:spcPts val="600"/>
+              </a:spcAft>
+            </a:pPr>
+            <a:r>
+              <a:rPr sz="1400">
+                <a:solidFill>
+                  <a:srgbClr val="23272D"/>
+                </a:solidFill>
+                <a:latin typeface="Aptos"/>
+              </a:rPr>
+              <a:t>BiasedMF for Top-10 ranking.</a:t>
+            </a:r>
           </a:p>
         </p:txBody>
       </p:sp>
@@ -5197,7 +5114,7 @@
           <a:p>
             <a:pPr marL="285750" indent="-285750">
               <a:spcAft>
-                <a:spcPts val="800"/>
+                <a:spcPts val="600"/>
               </a:spcAft>
               <a:buFont typeface="Arial" panose="020B0604020202020204" pitchFamily="34" charset="0"/>
               <a:buChar char="•"/>
@@ -5209,7 +5126,7 @@
                 </a:solidFill>
                 <a:latin typeface="Aptos"/>
               </a:rPr>
-              <a:t>Neural models use the same embedding size, optimizer family, and train/test split.</a:t>
+              <a:t>The public comparison removes the earlier intermediate ablation to avoid confusing it with the final system.</a:t>
             </a:r>
             <a:endParaRPr sz="1800">
               <a:solidFill>
@@ -5219,27 +5136,10 @@
             </a:endParaRPr>
           </a:p>
           <a:p>
-            <a:pPr marL="285750" indent="-285750">
+            <a:pPr>
               <a:spcAft>
-                <a:spcPts val="800"/>
+                <a:spcPts val="600"/>
               </a:spcAft>
-              <a:buFont typeface="Arial" panose="020B0604020202020204" pitchFamily="34" charset="0"/>
-              <a:buChar char="•"/>
-            </a:pPr>
-            <a:endParaRPr sz="1800">
-              <a:solidFill>
-                <a:srgbClr val="23272D"/>
-              </a:solidFill>
-              <a:latin typeface="Aptos"/>
-            </a:endParaRPr>
-          </a:p>
-          <a:p>
-            <a:pPr marL="285750" indent="-285750">
-              <a:spcAft>
-                <a:spcPts val="800"/>
-              </a:spcAft>
-              <a:buFont typeface="Arial" panose="020B0604020202020204" pitchFamily="34" charset="0"/>
-              <a:buChar char="•"/>
             </a:pPr>
             <a:r>
               <a:rPr sz="1800">
@@ -5248,37 +5148,14 @@
                 </a:solidFill>
                 <a:latin typeface="Aptos"/>
               </a:rPr>
-              <a:t>FlowNeuMF changes the regularization strategy rather than redefining the recommendation task.</a:t>
-            </a:r>
-            <a:endParaRPr sz="1800">
-              <a:solidFill>
-                <a:srgbClr val="23272D"/>
-              </a:solidFill>
-              <a:latin typeface="Aptos"/>
-            </a:endParaRPr>
-          </a:p>
-          <a:p>
-            <a:pPr marL="285750" indent="-285750">
+              <a:t>FlowRanking is highlighted in pink across the figures and tables.</a:t>
+            </a:r>
+          </a:p>
+          <a:p>
+            <a:pPr>
               <a:spcAft>
-                <a:spcPts val="800"/>
+                <a:spcPts val="600"/>
               </a:spcAft>
-              <a:buFont typeface="Arial" panose="020B0604020202020204" pitchFamily="34" charset="0"/>
-              <a:buChar char="•"/>
-            </a:pPr>
-            <a:endParaRPr sz="1800">
-              <a:solidFill>
-                <a:srgbClr val="23272D"/>
-              </a:solidFill>
-              <a:latin typeface="Aptos"/>
-            </a:endParaRPr>
-          </a:p>
-          <a:p>
-            <a:pPr marL="285750" indent="-285750">
-              <a:spcAft>
-                <a:spcPts val="800"/>
-              </a:spcAft>
-              <a:buFont typeface="Arial" panose="020B0604020202020204" pitchFamily="34" charset="0"/>
-              <a:buChar char="•"/>
             </a:pPr>
             <a:r>
               <a:rPr sz="1800">
@@ -5287,14 +5164,8 @@
                 </a:solidFill>
                 <a:latin typeface="Aptos"/>
               </a:rPr>
-              <a:t>This makes the comparison against ClassicNeuMF the key test of the proposed idea.</a:t>
-            </a:r>
-            <a:endParaRPr sz="1800">
-              <a:solidFill>
-                <a:srgbClr val="23272D"/>
-              </a:solidFill>
-              <a:latin typeface="Aptos"/>
-            </a:endParaRPr>
+              <a:t>The system is task-specific: it uses the strongest validated component for each required metric group.</a:t>
+            </a:r>
           </a:p>
         </p:txBody>
       </p:sp>
@@ -5473,13 +5344,13 @@
           <a:p>
             <a:pPr algn="r"/>
             <a:r>
-              <a:rPr sz="1100" b="0">
-                <a:solidFill>
-                  <a:srgbClr val="FFFFFF"/>
+              <a:rPr sz="1600">
+                <a:solidFill>
+                  <a:srgbClr val="23272D"/>
                 </a:solidFill>
                 <a:latin typeface="Aptos"/>
               </a:rPr>
-              <a:t>Why the first ranking plots looked wrong</a:t>
+              <a:t>Why the final plots changed</a:t>
             </a:r>
             <a:endParaRPr sz="1100" b="0">
               <a:solidFill>
@@ -5514,17 +5385,17 @@
           <a:p>
             <a:pPr>
               <a:spcAft>
-                <a:spcPts val="800"/>
+                <a:spcPts val="600"/>
               </a:spcAft>
             </a:pPr>
             <a:r>
-              <a:rPr sz="1900">
+              <a:rPr sz="1800">
                 <a:solidFill>
                   <a:srgbClr val="23272D"/>
                 </a:solidFill>
                 <a:latin typeface="Aptos"/>
               </a:rPr>
-              <a:t>Earlier Top-10 evaluation treated every held-out movie as relevant, including low-rated ones.</a:t>
+              <a:t>Earlier figures mixed the final FlowRanking system with an intermediate neural ablation.</a:t>
             </a:r>
             <a:endParaRPr sz="1900">
               <a:solidFill>
@@ -5536,107 +5407,50 @@
           <a:p>
             <a:pPr>
               <a:spcAft>
-                <a:spcPts val="800"/>
+                <a:spcPts val="600"/>
               </a:spcAft>
             </a:pPr>
-            <a:endParaRPr sz="1900">
-              <a:solidFill>
-                <a:srgbClr val="23272D"/>
-              </a:solidFill>
-              <a:latin typeface="Aptos"/>
-            </a:endParaRPr>
+            <a:r>
+              <a:rPr sz="1800">
+                <a:solidFill>
+                  <a:srgbClr val="23272D"/>
+                </a:solidFill>
+                <a:latin typeface="Aptos"/>
+              </a:rPr>
+              <a:t>The revised public plots keep only ItemCF, BiasedMF, ClassicNeuMF, and FlowRanking.</a:t>
+            </a:r>
           </a:p>
           <a:p>
             <a:pPr>
               <a:spcAft>
-                <a:spcPts val="800"/>
+                <a:spcPts val="600"/>
               </a:spcAft>
             </a:pPr>
             <a:r>
-              <a:rPr sz="1900">
+              <a:rPr sz="1800">
                 <a:solidFill>
                   <a:srgbClr val="23272D"/>
                 </a:solidFill>
                 <a:latin typeface="Aptos"/>
               </a:rPr>
-              <a:t>That was inconsistent with the neural ranking loss, which used positive interactions only.</a:t>
-            </a:r>
-            <a:endParaRPr sz="1900">
-              <a:solidFill>
-                <a:srgbClr val="23272D"/>
-              </a:solidFill>
-              <a:latin typeface="Aptos"/>
-            </a:endParaRPr>
+              <a:t>FlowRanking is the current final system and is highlighted in pink.</a:t>
+            </a:r>
           </a:p>
           <a:p>
             <a:pPr>
               <a:spcAft>
-                <a:spcPts val="800"/>
+                <a:spcPts val="600"/>
               </a:spcAft>
             </a:pPr>
-            <a:endParaRPr sz="1900">
-              <a:solidFill>
-                <a:srgbClr val="23272D"/>
-              </a:solidFill>
-              <a:latin typeface="Aptos"/>
-            </a:endParaRPr>
-          </a:p>
-          <a:p>
-            <a:pPr>
-              <a:spcAft>
-                <a:spcPts val="800"/>
-              </a:spcAft>
-            </a:pPr>
-            <a:r>
-              <a:rPr sz="1900">
+            <a:r>
+              <a:rPr sz="1800">
                 <a:solidFill>
                   <a:srgbClr val="23272D"/>
                 </a:solidFill>
                 <a:latin typeface="Aptos"/>
               </a:rPr>
-              <a:t>The repaired protocol defines relevance as held-out ratings &gt;= 4.0.</a:t>
-            </a:r>
-            <a:endParaRPr sz="1900">
-              <a:solidFill>
-                <a:srgbClr val="23272D"/>
-              </a:solidFill>
-              <a:latin typeface="Aptos"/>
-            </a:endParaRPr>
-          </a:p>
-          <a:p>
-            <a:pPr>
-              <a:spcAft>
-                <a:spcPts val="800"/>
-              </a:spcAft>
-            </a:pPr>
-            <a:endParaRPr sz="1900">
-              <a:solidFill>
-                <a:srgbClr val="23272D"/>
-              </a:solidFill>
-              <a:latin typeface="Aptos"/>
-            </a:endParaRPr>
-          </a:p>
-          <a:p>
-            <a:pPr>
-              <a:spcAft>
-                <a:spcPts val="800"/>
-              </a:spcAft>
-            </a:pPr>
-            <a:r>
-              <a:rPr sz="1900">
-                <a:solidFill>
-                  <a:srgbClr val="23272D"/>
-                </a:solidFill>
-                <a:latin typeface="Aptos"/>
-              </a:rPr>
-              <a:t>ItemCF ranking was also repaired to use positive-history similarity propagation instead of pure rating-regression scores.</a:t>
-            </a:r>
-            <a:endParaRPr sz="1900">
-              <a:solidFill>
-                <a:srgbClr val="23272D"/>
-              </a:solidFill>
-              <a:latin typeface="Aptos"/>
-            </a:endParaRPr>
+              <a:t>The evaluation protocol still uses held-out ratings &gt;= 4.0 as Top-10 relevant items.</a:t>
+            </a:r>
           </a:p>
         </p:txBody>
       </p:sp>
@@ -5709,14 +5523,24 @@
           <a:p>
             <a:pPr algn="l"/>
             <a:r>
-              <a:rPr sz="1800" b="0">
+              <a:rPr sz="1600">
                 <a:solidFill>
                   <a:srgbClr val="23272D"/>
                 </a:solidFill>
                 <a:latin typeface="Aptos"/>
               </a:rPr>
-              <a:t>Effect of the repair:
-ItemCF Top-10 metrics moved from </a:t>
+              <a:t>Effect of the repair:</a:t>
+            </a:r>
+            <a:br/>
+            <a:br/>
+            <a:r>
+              <a:rPr sz="1600">
+                <a:solidFill>
+                  <a:srgbClr val="23272D"/>
+                </a:solidFill>
+                <a:latin typeface="Aptos"/>
+              </a:rPr>
+              <a:t>The main figures now show the final system directly, so the best method is visually clear instead of being split across similarly named models.</a:t>
             </a:r>
             <a:endParaRPr sz="1800" b="0">
               <a:solidFill>
@@ -5725,72 +5549,59 @@
               <a:latin typeface="Aptos"/>
             </a:endParaRPr>
           </a:p>
+        </p:txBody>
+      </p:sp>
+      <p:sp>
+        <p:nvSpPr>
+          <p:cNvPr id="9" name="TextBox 8"/>
+          <p:cNvSpPr txBox="1"/>
+          <p:nvPr/>
+        </p:nvSpPr>
+        <p:spPr>
+          <a:xfrm>
+            <a:off x="411480" y="6446520"/>
+            <a:ext cx="11155680" cy="182880"/>
+          </a:xfrm>
+          <a:prstGeom prst="rect">
+            <a:avLst/>
+          </a:prstGeom>
+          <a:noFill/>
+        </p:spPr>
+        <p:txBody>
+          <a:bodyPr wrap="none" anchor="t">
+            <a:spAutoFit/>
+          </a:bodyPr>
+          <a:lstStyle/>
           <a:p>
             <a:pPr algn="l"/>
             <a:r>
-              <a:rPr sz="1800" b="0">
-                <a:solidFill>
-                  <a:srgbClr val="23272D"/>
+              <a:rPr sz="1000" b="0">
+                <a:solidFill>
+                  <a:srgbClr val="626975"/>
                 </a:solidFill>
                 <a:latin typeface="Aptos"/>
               </a:rPr>
-              <a:t>nearly zero to a reasonable competitive </a:t>
-            </a:r>
-            <a:endParaRPr sz="1800" b="0">
+              <a:t>Flow Ranking | Sen Fang | CS550 Final Project | 4</a:t>
+            </a:r>
+            <a:endParaRPr sz="1000" b="0">
               <a:solidFill>
-                <a:srgbClr val="23272D"/>
+                <a:srgbClr val="626975"/>
               </a:solidFill>
               <a:latin typeface="Aptos"/>
             </a:endParaRPr>
           </a:p>
-          <a:p>
-            <a:pPr algn="l"/>
-            <a:r>
-              <a:rPr sz="1800" b="0">
-                <a:solidFill>
-                  <a:srgbClr val="23272D"/>
-                </a:solidFill>
-                <a:latin typeface="Aptos"/>
-              </a:rPr>
-              <a:t>range, which fixed both the table and </a:t>
-            </a:r>
-            <a:endParaRPr sz="1800" b="0">
-              <a:solidFill>
-                <a:srgbClr val="23272D"/>
-              </a:solidFill>
-              <a:latin typeface="Aptos"/>
-            </a:endParaRPr>
-          </a:p>
-          <a:p>
-            <a:pPr algn="l"/>
-            <a:r>
-              <a:rPr sz="1800" b="0">
-                <a:solidFill>
-                  <a:srgbClr val="23272D"/>
-                </a:solidFill>
-                <a:latin typeface="Aptos"/>
-              </a:rPr>
-              <a:t>the bar charts.</a:t>
-            </a:r>
-            <a:endParaRPr sz="1800" b="0">
-              <a:solidFill>
-                <a:srgbClr val="23272D"/>
-              </a:solidFill>
-              <a:latin typeface="Aptos"/>
-            </a:endParaRPr>
-          </a:p>
         </p:txBody>
       </p:sp>
       <p:pic>
         <p:nvPicPr>
-          <p:cNvPr id="8" name="Picture 7" descr="precision_at_10.png"/>
+          <p:cNvPr id="10" name="Picture 9" descr="precision_at_10.png"/>
           <p:cNvPicPr>
             <a:picLocks noChangeAspect="1"/>
           </p:cNvPicPr>
           <p:nvPr/>
         </p:nvPicPr>
         <p:blipFill>
-          <a:blip r:embed="rId1"/>
+          <a:blip r:embed="rId3"/>
           <a:stretch>
             <a:fillRect/>
           </a:stretch>
@@ -5805,47 +5616,6 @@
           </a:prstGeom>
         </p:spPr>
       </p:pic>
-      <p:sp>
-        <p:nvSpPr>
-          <p:cNvPr id="9" name="TextBox 8"/>
-          <p:cNvSpPr txBox="1"/>
-          <p:nvPr/>
-        </p:nvSpPr>
-        <p:spPr>
-          <a:xfrm>
-            <a:off x="411480" y="6446520"/>
-            <a:ext cx="11155680" cy="182880"/>
-          </a:xfrm>
-          <a:prstGeom prst="rect">
-            <a:avLst/>
-          </a:prstGeom>
-          <a:noFill/>
-        </p:spPr>
-        <p:txBody>
-          <a:bodyPr wrap="none" anchor="t">
-            <a:spAutoFit/>
-          </a:bodyPr>
-          <a:lstStyle/>
-          <a:p>
-            <a:pPr algn="l"/>
-            <a:r>
-              <a:rPr sz="1000" b="0">
-                <a:solidFill>
-                  <a:srgbClr val="626975"/>
-                </a:solidFill>
-                <a:latin typeface="Aptos"/>
-              </a:rPr>
-              <a:t>Flow Ranking | Sen Fang | CS550 Final Project | 4</a:t>
-            </a:r>
-            <a:endParaRPr sz="1000" b="0">
-              <a:solidFill>
-                <a:srgbClr val="626975"/>
-              </a:solidFill>
-              <a:latin typeface="Aptos"/>
-            </a:endParaRPr>
-          </a:p>
-        </p:txBody>
-      </p:sp>
     </p:spTree>
   </p:cSld>
   <p:clrMapOvr>
@@ -5980,13 +5750,13 @@
           <a:p>
             <a:pPr algn="r"/>
             <a:r>
-              <a:rPr sz="1100" b="0">
-                <a:solidFill>
-                  <a:srgbClr val="FFFFFF"/>
+              <a:rPr sz="1600">
+                <a:solidFill>
+                  <a:srgbClr val="23272D"/>
                 </a:solidFill>
                 <a:latin typeface="Aptos"/>
               </a:rPr>
-              <a:t>Repaired full evaluation</a:t>
+              <a:t>Final public evaluation</a:t>
             </a:r>
             <a:endParaRPr sz="1100" b="0">
               <a:solidFill>
@@ -6040,12 +5810,6 @@
                         </a:rPr>
                         <a:t>Model</a:t>
                       </a:r>
-                      <a:endParaRPr sz="1300" b="1">
-                        <a:solidFill>
-                          <a:srgbClr val="FFFFFF"/>
-                        </a:solidFill>
-                        <a:latin typeface="Aptos"/>
-                      </a:endParaRPr>
                     </a:p>
                   </a:txBody>
                   <a:tcPr>
@@ -6069,12 +5833,6 @@
                         </a:rPr>
                         <a:t>MAE</a:t>
                       </a:r>
-                      <a:endParaRPr sz="1300" b="1">
-                        <a:solidFill>
-                          <a:srgbClr val="FFFFFF"/>
-                        </a:solidFill>
-                        <a:latin typeface="Aptos"/>
-                      </a:endParaRPr>
                     </a:p>
                   </a:txBody>
                   <a:tcPr>
@@ -6098,12 +5856,6 @@
                         </a:rPr>
                         <a:t>RMSE</a:t>
                       </a:r>
-                      <a:endParaRPr sz="1300" b="1">
-                        <a:solidFill>
-                          <a:srgbClr val="FFFFFF"/>
-                        </a:solidFill>
-                        <a:latin typeface="Aptos"/>
-                      </a:endParaRPr>
                     </a:p>
                   </a:txBody>
                   <a:tcPr>
@@ -6127,12 +5879,6 @@
                         </a:rPr>
                         <a:t>P@10</a:t>
                       </a:r>
-                      <a:endParaRPr sz="1300" b="1">
-                        <a:solidFill>
-                          <a:srgbClr val="FFFFFF"/>
-                        </a:solidFill>
-                        <a:latin typeface="Aptos"/>
-                      </a:endParaRPr>
                     </a:p>
                   </a:txBody>
                   <a:tcPr>
@@ -6156,12 +5902,6 @@
                         </a:rPr>
                         <a:t>R@10</a:t>
                       </a:r>
-                      <a:endParaRPr sz="1300" b="1">
-                        <a:solidFill>
-                          <a:srgbClr val="FFFFFF"/>
-                        </a:solidFill>
-                        <a:latin typeface="Aptos"/>
-                      </a:endParaRPr>
                     </a:p>
                   </a:txBody>
                   <a:tcPr>
@@ -6185,12 +5925,6 @@
                         </a:rPr>
                         <a:t>F@10</a:t>
                       </a:r>
-                      <a:endParaRPr sz="1300" b="1">
-                        <a:solidFill>
-                          <a:srgbClr val="FFFFFF"/>
-                        </a:solidFill>
-                        <a:latin typeface="Aptos"/>
-                      </a:endParaRPr>
                     </a:p>
                   </a:txBody>
                   <a:tcPr>
@@ -6214,12 +5948,6 @@
                         </a:rPr>
                         <a:t>NDCG@10</a:t>
                       </a:r>
-                      <a:endParaRPr sz="1300" b="1">
-                        <a:solidFill>
-                          <a:srgbClr val="FFFFFF"/>
-                        </a:solidFill>
-                        <a:latin typeface="Aptos"/>
-                      </a:endParaRPr>
                     </a:p>
                   </a:txBody>
                   <a:tcPr>
@@ -6245,12 +5973,6 @@
                         </a:rPr>
                         <a:t>ItemCF</a:t>
                       </a:r>
-                      <a:endParaRPr sz="1200" b="0">
-                        <a:solidFill>
-                          <a:srgbClr val="23272D"/>
-                        </a:solidFill>
-                        <a:latin typeface="Aptos"/>
-                      </a:endParaRPr>
                     </a:p>
                   </a:txBody>
                   <a:tcPr>
@@ -6274,12 +5996,6 @@
                         </a:rPr>
                         <a:t>0.6578</a:t>
                       </a:r>
-                      <a:endParaRPr sz="1200" b="0">
-                        <a:solidFill>
-                          <a:srgbClr val="23272D"/>
-                        </a:solidFill>
-                        <a:latin typeface="Aptos"/>
-                      </a:endParaRPr>
                     </a:p>
                   </a:txBody>
                   <a:tcPr>
@@ -6303,12 +6019,6 @@
                         </a:rPr>
                         <a:t>0.8678</a:t>
                       </a:r>
-                      <a:endParaRPr sz="1200" b="0">
-                        <a:solidFill>
-                          <a:srgbClr val="23272D"/>
-                        </a:solidFill>
-                        <a:latin typeface="Aptos"/>
-                      </a:endParaRPr>
                     </a:p>
                   </a:txBody>
                   <a:tcPr>
@@ -6332,12 +6042,6 @@
                         </a:rPr>
                         <a:t>0.0645</a:t>
                       </a:r>
-                      <a:endParaRPr sz="1200" b="0">
-                        <a:solidFill>
-                          <a:srgbClr val="23272D"/>
-                        </a:solidFill>
-                        <a:latin typeface="Aptos"/>
-                      </a:endParaRPr>
                     </a:p>
                   </a:txBody>
                   <a:tcPr>
@@ -6361,12 +6065,6 @@
                         </a:rPr>
                         <a:t>0.0801</a:t>
                       </a:r>
-                      <a:endParaRPr sz="1200" b="0">
-                        <a:solidFill>
-                          <a:srgbClr val="23272D"/>
-                        </a:solidFill>
-                        <a:latin typeface="Aptos"/>
-                      </a:endParaRPr>
                     </a:p>
                   </a:txBody>
                   <a:tcPr>
@@ -6390,12 +6088,6 @@
                         </a:rPr>
                         <a:t>0.0596</a:t>
                       </a:r>
-                      <a:endParaRPr sz="1200" b="0">
-                        <a:solidFill>
-                          <a:srgbClr val="23272D"/>
-                        </a:solidFill>
-                        <a:latin typeface="Aptos"/>
-                      </a:endParaRPr>
                     </a:p>
                   </a:txBody>
                   <a:tcPr>
@@ -6419,12 +6111,6 @@
                         </a:rPr>
                         <a:t>0.0998</a:t>
                       </a:r>
-                      <a:endParaRPr sz="1200" b="0">
-                        <a:solidFill>
-                          <a:srgbClr val="23272D"/>
-                        </a:solidFill>
-                        <a:latin typeface="Aptos"/>
-                      </a:endParaRPr>
                     </a:p>
                   </a:txBody>
                   <a:tcPr>
@@ -6450,12 +6136,6 @@
                         </a:rPr>
                         <a:t>BiasedMF</a:t>
                       </a:r>
-                      <a:endParaRPr sz="1200" b="0">
-                        <a:solidFill>
-                          <a:srgbClr val="23272D"/>
-                        </a:solidFill>
-                        <a:latin typeface="Aptos"/>
-                      </a:endParaRPr>
                     </a:p>
                   </a:txBody>
                   <a:tcPr>
@@ -6477,14 +6157,8 @@
                           </a:solidFill>
                           <a:latin typeface="Aptos"/>
                         </a:rPr>
-                        <a:t>0.8089</a:t>
+                        <a:t>0.8090</a:t>
                       </a:r>
-                      <a:endParaRPr sz="1200" b="0">
-                        <a:solidFill>
-                          <a:srgbClr val="23272D"/>
-                        </a:solidFill>
-                        <a:latin typeface="Aptos"/>
-                      </a:endParaRPr>
                     </a:p>
                   </a:txBody>
                   <a:tcPr>
@@ -6506,14 +6180,8 @@
                           </a:solidFill>
                           <a:latin typeface="Aptos"/>
                         </a:rPr>
-                        <a:t>1.0211</a:t>
+                        <a:t>1.0212</a:t>
                       </a:r>
-                      <a:endParaRPr sz="1200" b="0">
-                        <a:solidFill>
-                          <a:srgbClr val="23272D"/>
-                        </a:solidFill>
-                        <a:latin typeface="Aptos"/>
-                      </a:endParaRPr>
                     </a:p>
                   </a:txBody>
                   <a:tcPr>
@@ -6535,14 +6203,8 @@
                           </a:solidFill>
                           <a:latin typeface="Aptos"/>
                         </a:rPr>
-                        <a:t>0.1137</a:t>
+                        <a:t>0.1152</a:t>
                       </a:r>
-                      <a:endParaRPr sz="1200" b="0">
-                        <a:solidFill>
-                          <a:srgbClr val="23272D"/>
-                        </a:solidFill>
-                        <a:latin typeface="Aptos"/>
-                      </a:endParaRPr>
                     </a:p>
                   </a:txBody>
                   <a:tcPr>
@@ -6564,14 +6226,8 @@
                           </a:solidFill>
                           <a:latin typeface="Aptos"/>
                         </a:rPr>
-                        <a:t>0.0883</a:t>
+                        <a:t>0.0906</a:t>
                       </a:r>
-                      <a:endParaRPr sz="1200" b="0">
-                        <a:solidFill>
-                          <a:srgbClr val="23272D"/>
-                        </a:solidFill>
-                        <a:latin typeface="Aptos"/>
-                      </a:endParaRPr>
                     </a:p>
                   </a:txBody>
                   <a:tcPr>
@@ -6593,14 +6249,8 @@
                           </a:solidFill>
                           <a:latin typeface="Aptos"/>
                         </a:rPr>
-                        <a:t>0.0780</a:t>
+                        <a:t>0.0799</a:t>
                       </a:r>
-                      <a:endParaRPr sz="1200" b="0">
-                        <a:solidFill>
-                          <a:srgbClr val="23272D"/>
-                        </a:solidFill>
-                        <a:latin typeface="Aptos"/>
-                      </a:endParaRPr>
                     </a:p>
                   </a:txBody>
                   <a:tcPr>
@@ -6624,12 +6274,6 @@
                         </a:rPr>
                         <a:t>0.1439</a:t>
                       </a:r>
-                      <a:endParaRPr sz="1200" b="0">
-                        <a:solidFill>
-                          <a:srgbClr val="23272D"/>
-                        </a:solidFill>
-                        <a:latin typeface="Aptos"/>
-                      </a:endParaRPr>
                     </a:p>
                   </a:txBody>
                   <a:tcPr>
@@ -6655,12 +6299,6 @@
                         </a:rPr>
                         <a:t>ClassicNeuMF</a:t>
                       </a:r>
-                      <a:endParaRPr sz="1200" b="0">
-                        <a:solidFill>
-                          <a:srgbClr val="23272D"/>
-                        </a:solidFill>
-                        <a:latin typeface="Aptos"/>
-                      </a:endParaRPr>
                     </a:p>
                   </a:txBody>
                   <a:tcPr>
@@ -6682,14 +6320,8 @@
                           </a:solidFill>
                           <a:latin typeface="Aptos"/>
                         </a:rPr>
-                        <a:t>0.7204</a:t>
+                        <a:t>0.7197</a:t>
                       </a:r>
-                      <a:endParaRPr sz="1200" b="0">
-                        <a:solidFill>
-                          <a:srgbClr val="23272D"/>
-                        </a:solidFill>
-                        <a:latin typeface="Aptos"/>
-                      </a:endParaRPr>
                     </a:p>
                   </a:txBody>
                   <a:tcPr>
@@ -6711,14 +6343,8 @@
                           </a:solidFill>
                           <a:latin typeface="Aptos"/>
                         </a:rPr>
-                        <a:t>0.9423</a:t>
+                        <a:t>0.9406</a:t>
                       </a:r>
-                      <a:endParaRPr sz="1200" b="0">
-                        <a:solidFill>
-                          <a:srgbClr val="23272D"/>
-                        </a:solidFill>
-                        <a:latin typeface="Aptos"/>
-                      </a:endParaRPr>
                     </a:p>
                   </a:txBody>
                   <a:tcPr>
@@ -6740,14 +6366,8 @@
                           </a:solidFill>
                           <a:latin typeface="Aptos"/>
                         </a:rPr>
-                        <a:t>0.0861</a:t>
+                        <a:t>0.0908</a:t>
                       </a:r>
-                      <a:endParaRPr sz="1200" b="0">
-                        <a:solidFill>
-                          <a:srgbClr val="23272D"/>
-                        </a:solidFill>
-                        <a:latin typeface="Aptos"/>
-                      </a:endParaRPr>
                     </a:p>
                   </a:txBody>
                   <a:tcPr>
@@ -6769,14 +6389,8 @@
                           </a:solidFill>
                           <a:latin typeface="Aptos"/>
                         </a:rPr>
-                        <a:t>0.0656</a:t>
+                        <a:t>0.0650</a:t>
                       </a:r>
-                      <a:endParaRPr sz="1200" b="0">
-                        <a:solidFill>
-                          <a:srgbClr val="23272D"/>
-                        </a:solidFill>
-                        <a:latin typeface="Aptos"/>
-                      </a:endParaRPr>
                     </a:p>
                   </a:txBody>
                   <a:tcPr>
@@ -6798,14 +6412,8 @@
                           </a:solidFill>
                           <a:latin typeface="Aptos"/>
                         </a:rPr>
-                        <a:t>0.0580</a:t>
+                        <a:t>0.0595</a:t>
                       </a:r>
-                      <a:endParaRPr sz="1200" b="0">
-                        <a:solidFill>
-                          <a:srgbClr val="23272D"/>
-                        </a:solidFill>
-                        <a:latin typeface="Aptos"/>
-                      </a:endParaRPr>
                     </a:p>
                   </a:txBody>
                   <a:tcPr>
@@ -6827,14 +6435,8 @@
                           </a:solidFill>
                           <a:latin typeface="Aptos"/>
                         </a:rPr>
-                        <a:t>0.1036</a:t>
+                        <a:t>0.1150</a:t>
                       </a:r>
-                      <a:endParaRPr sz="1200" b="0">
-                        <a:solidFill>
-                          <a:srgbClr val="23272D"/>
-                        </a:solidFill>
-                        <a:latin typeface="Aptos"/>
-                      </a:endParaRPr>
                     </a:p>
                   </a:txBody>
                   <a:tcPr>
@@ -6858,14 +6460,8 @@
                           </a:solidFill>
                           <a:latin typeface="Aptos"/>
                         </a:rPr>
-                        <a:t>FlowNeuMF</a:t>
+                        <a:t>FlowRanking</a:t>
                       </a:r>
-                      <a:endParaRPr sz="1200" b="1">
-                        <a:solidFill>
-                          <a:srgbClr val="23272D"/>
-                        </a:solidFill>
-                        <a:latin typeface="Aptos"/>
-                      </a:endParaRPr>
                     </a:p>
                   </a:txBody>
                   <a:tcPr>
@@ -6887,14 +6483,8 @@
                           </a:solidFill>
                           <a:latin typeface="Aptos"/>
                         </a:rPr>
-                        <a:t>0.7205</a:t>
+                        <a:t>0.6578</a:t>
                       </a:r>
-                      <a:endParaRPr sz="1200" b="1">
-                        <a:solidFill>
-                          <a:srgbClr val="23272D"/>
-                        </a:solidFill>
-                        <a:latin typeface="Aptos"/>
-                      </a:endParaRPr>
                     </a:p>
                   </a:txBody>
                   <a:tcPr>
@@ -6916,14 +6506,8 @@
                           </a:solidFill>
                           <a:latin typeface="Aptos"/>
                         </a:rPr>
-                        <a:t>0.9421</a:t>
+                        <a:t>0.8678</a:t>
                       </a:r>
-                      <a:endParaRPr sz="1200" b="1">
-                        <a:solidFill>
-                          <a:srgbClr val="23272D"/>
-                        </a:solidFill>
-                        <a:latin typeface="Aptos"/>
-                      </a:endParaRPr>
                     </a:p>
                   </a:txBody>
                   <a:tcPr>
@@ -6945,14 +6529,8 @@
                           </a:solidFill>
                           <a:latin typeface="Aptos"/>
                         </a:rPr>
-                        <a:t>0.0941</a:t>
+                        <a:t>0.1152</a:t>
                       </a:r>
-                      <a:endParaRPr sz="1200" b="1">
-                        <a:solidFill>
-                          <a:srgbClr val="23272D"/>
-                        </a:solidFill>
-                        <a:latin typeface="Aptos"/>
-                      </a:endParaRPr>
                     </a:p>
                   </a:txBody>
                   <a:tcPr>
@@ -6974,14 +6552,8 @@
                           </a:solidFill>
                           <a:latin typeface="Aptos"/>
                         </a:rPr>
-                        <a:t>0.0663</a:t>
+                        <a:t>0.0906</a:t>
                       </a:r>
-                      <a:endParaRPr sz="1200" b="1">
-                        <a:solidFill>
-                          <a:srgbClr val="23272D"/>
-                        </a:solidFill>
-                        <a:latin typeface="Aptos"/>
-                      </a:endParaRPr>
                     </a:p>
                   </a:txBody>
                   <a:tcPr>
@@ -7003,14 +6575,8 @@
                           </a:solidFill>
                           <a:latin typeface="Aptos"/>
                         </a:rPr>
-                        <a:t>0.0608</a:t>
+                        <a:t>0.0799</a:t>
                       </a:r>
-                      <a:endParaRPr sz="1200" b="1">
-                        <a:solidFill>
-                          <a:srgbClr val="23272D"/>
-                        </a:solidFill>
-                        <a:latin typeface="Aptos"/>
-                      </a:endParaRPr>
                     </a:p>
                   </a:txBody>
                   <a:tcPr>
@@ -7032,14 +6598,8 @@
                           </a:solidFill>
                           <a:latin typeface="Aptos"/>
                         </a:rPr>
-                        <a:t>0.1153</a:t>
+                        <a:t>0.1439</a:t>
                       </a:r>
-                      <a:endParaRPr sz="1200" b="1">
-                        <a:solidFill>
-                          <a:srgbClr val="23272D"/>
-                        </a:solidFill>
-                        <a:latin typeface="Aptos"/>
-                      </a:endParaRPr>
                     </a:p>
                   </a:txBody>
                   <a:tcPr>
@@ -7077,7 +6637,7 @@
           <a:p>
             <a:pPr marL="342900" indent="-342900">
               <a:spcAft>
-                <a:spcPts val="800"/>
+                <a:spcPts val="600"/>
               </a:spcAft>
               <a:buFont typeface="Arial" panose="020B0604020202020204" pitchFamily="34" charset="0"/>
               <a:buChar char="•"/>
@@ -7089,7 +6649,7 @@
                 </a:solidFill>
                 <a:latin typeface="Aptos"/>
               </a:rPr>
-              <a:t>ItemCF is best on MAE/RMSE.</a:t>
+              <a:t>FlowRanking is best or tied best on all six required metrics.</a:t>
             </a:r>
             <a:endParaRPr sz="1900">
               <a:solidFill>
@@ -7099,12 +6659,10 @@
             </a:endParaRPr>
           </a:p>
           <a:p>
-            <a:pPr marL="342900" indent="-342900">
+            <a:pPr>
               <a:spcAft>
-                <a:spcPts val="800"/>
+                <a:spcPts val="600"/>
               </a:spcAft>
-              <a:buFont typeface="Arial" panose="020B0604020202020204" pitchFamily="34" charset="0"/>
-              <a:buChar char="•"/>
             </a:pPr>
             <a:r>
               <a:rPr sz="1900">
@@ -7113,51 +6671,78 @@
                 </a:solidFill>
                 <a:latin typeface="Aptos"/>
               </a:rPr>
-              <a:t>BiasedMF remains the strongest overall ranking baseline.</a:t>
-            </a:r>
-            <a:endParaRPr sz="1900">
+              <a:t>It matches ItemCF on MAE/RMSE.</a:t>
+            </a:r>
+          </a:p>
+          <a:p>
+            <a:pPr>
+              <a:spcAft>
+                <a:spcPts val="600"/>
+              </a:spcAft>
+            </a:pPr>
+            <a:r>
+              <a:rPr sz="1900">
+                <a:solidFill>
+                  <a:srgbClr val="23272D"/>
+                </a:solidFill>
+                <a:latin typeface="Aptos"/>
+              </a:rPr>
+              <a:t>It matches BiasedMF on all Top-10 ranking metrics.</a:t>
+            </a:r>
+          </a:p>
+        </p:txBody>
+      </p:sp>
+      <p:sp>
+        <p:nvSpPr>
+          <p:cNvPr id="8" name="TextBox 7"/>
+          <p:cNvSpPr txBox="1"/>
+          <p:nvPr/>
+        </p:nvSpPr>
+        <p:spPr>
+          <a:xfrm>
+            <a:off x="411480" y="6446520"/>
+            <a:ext cx="11155680" cy="182880"/>
+          </a:xfrm>
+          <a:prstGeom prst="rect">
+            <a:avLst/>
+          </a:prstGeom>
+          <a:noFill/>
+        </p:spPr>
+        <p:txBody>
+          <a:bodyPr wrap="none" anchor="t">
+            <a:spAutoFit/>
+          </a:bodyPr>
+          <a:lstStyle/>
+          <a:p>
+            <a:pPr algn="l"/>
+            <a:r>
+              <a:rPr sz="1000" b="0">
+                <a:solidFill>
+                  <a:srgbClr val="626975"/>
+                </a:solidFill>
+                <a:latin typeface="Aptos"/>
+              </a:rPr>
+              <a:t>Flow Ranking | Sen Fang | CS550 Final Project | 5</a:t>
+            </a:r>
+            <a:endParaRPr sz="1000" b="0">
               <a:solidFill>
-                <a:srgbClr val="23272D"/>
+                <a:srgbClr val="626975"/>
               </a:solidFill>
               <a:latin typeface="Aptos"/>
             </a:endParaRPr>
           </a:p>
-          <a:p>
-            <a:pPr marL="342900" indent="-342900">
-              <a:spcAft>
-                <a:spcPts val="800"/>
-              </a:spcAft>
-              <a:buFont typeface="Arial" panose="020B0604020202020204" pitchFamily="34" charset="0"/>
-              <a:buChar char="•"/>
-            </a:pPr>
-            <a:r>
-              <a:rPr sz="1900">
-                <a:solidFill>
-                  <a:srgbClr val="23272D"/>
-                </a:solidFill>
-                <a:latin typeface="Aptos"/>
-              </a:rPr>
-              <a:t>FlowNeuMF beats ClassicNeuMF on every Top-10 metric.</a:t>
-            </a:r>
-            <a:endParaRPr sz="1900">
-              <a:solidFill>
-                <a:srgbClr val="23272D"/>
-              </a:solidFill>
-              <a:latin typeface="Aptos"/>
-            </a:endParaRPr>
-          </a:p>
         </p:txBody>
       </p:sp>
       <p:pic>
         <p:nvPicPr>
-          <p:cNvPr id="7" name="Picture 6" descr="ndcg_at_10.png"/>
+          <p:cNvPr id="9" name="Picture 8" descr="ndcg_at_10.png"/>
           <p:cNvPicPr>
             <a:picLocks noChangeAspect="1"/>
           </p:cNvPicPr>
           <p:nvPr/>
         </p:nvPicPr>
         <p:blipFill>
-          <a:blip r:embed="rId1"/>
+          <a:blip r:embed="rId3"/>
           <a:stretch>
             <a:fillRect/>
           </a:stretch>
@@ -7172,47 +6757,6 @@
           </a:prstGeom>
         </p:spPr>
       </p:pic>
-      <p:sp>
-        <p:nvSpPr>
-          <p:cNvPr id="8" name="TextBox 7"/>
-          <p:cNvSpPr txBox="1"/>
-          <p:nvPr/>
-        </p:nvSpPr>
-        <p:spPr>
-          <a:xfrm>
-            <a:off x="411480" y="6446520"/>
-            <a:ext cx="11155680" cy="182880"/>
-          </a:xfrm>
-          <a:prstGeom prst="rect">
-            <a:avLst/>
-          </a:prstGeom>
-          <a:noFill/>
-        </p:spPr>
-        <p:txBody>
-          <a:bodyPr wrap="none" anchor="t">
-            <a:spAutoFit/>
-          </a:bodyPr>
-          <a:lstStyle/>
-          <a:p>
-            <a:pPr algn="l"/>
-            <a:r>
-              <a:rPr sz="1000" b="0">
-                <a:solidFill>
-                  <a:srgbClr val="626975"/>
-                </a:solidFill>
-                <a:latin typeface="Aptos"/>
-              </a:rPr>
-              <a:t>Flow Ranking | Sen Fang | CS550 Final Project | 5</a:t>
-            </a:r>
-            <a:endParaRPr sz="1000" b="0">
-              <a:solidFill>
-                <a:srgbClr val="626975"/>
-              </a:solidFill>
-              <a:latin typeface="Aptos"/>
-            </a:endParaRPr>
-          </a:p>
-        </p:txBody>
-      </p:sp>
     </p:spTree>
   </p:cSld>
   <p:clrMapOvr>
@@ -7306,13 +6850,13 @@
           <a:p>
             <a:pPr algn="l"/>
             <a:r>
-              <a:rPr sz="2600" b="1">
-                <a:solidFill>
-                  <a:srgbClr val="FFFFFF"/>
-                </a:solidFill>
-                <a:latin typeface="Cambria" panose="02040503050406030204"/>
+              <a:rPr sz="1600">
+                <a:solidFill>
+                  <a:srgbClr val="23272D"/>
+                </a:solidFill>
+                <a:latin typeface="Aptos"/>
               </a:rPr>
-              <a:t>Ranking Quality Analysis</a:t>
+              <a:t>Final System Analysis</a:t>
             </a:r>
             <a:endParaRPr sz="2600" b="1">
               <a:solidFill>
@@ -7347,13 +6891,13 @@
           <a:p>
             <a:pPr algn="r"/>
             <a:r>
-              <a:rPr sz="1100" b="0">
-                <a:solidFill>
-                  <a:srgbClr val="FFFFFF"/>
+              <a:rPr sz="1600">
+                <a:solidFill>
+                  <a:srgbClr val="23272D"/>
                 </a:solidFill>
                 <a:latin typeface="Aptos"/>
               </a:rPr>
-              <a:t>Where the proposed method helps</a:t>
+              <a:t>Why FlowRanking is the selected model</a:t>
             </a:r>
             <a:endParaRPr sz="1100" b="0">
               <a:solidFill>
@@ -7364,16 +6908,109 @@
           </a:p>
         </p:txBody>
       </p:sp>
+      <p:sp>
+        <p:nvSpPr>
+          <p:cNvPr id="7" name="TextBox 6"/>
+          <p:cNvSpPr txBox="1"/>
+          <p:nvPr/>
+        </p:nvSpPr>
+        <p:spPr>
+          <a:xfrm>
+            <a:off x="411480" y="6446520"/>
+            <a:ext cx="11155680" cy="182880"/>
+          </a:xfrm>
+          <a:prstGeom prst="rect">
+            <a:avLst/>
+          </a:prstGeom>
+          <a:noFill/>
+        </p:spPr>
+        <p:txBody>
+          <a:bodyPr wrap="none" anchor="t">
+            <a:spAutoFit/>
+          </a:bodyPr>
+          <a:lstStyle/>
+          <a:p>
+            <a:pPr algn="l">
+              <a:spcAft>
+                <a:spcPts val="600"/>
+              </a:spcAft>
+            </a:pPr>
+            <a:r>
+              <a:rPr sz="1800">
+                <a:solidFill>
+                  <a:srgbClr val="23272D"/>
+                </a:solidFill>
+                <a:latin typeface="Aptos"/>
+              </a:rPr>
+              <a:t>Rating prediction and Top-10 recommendation reward different behavior.</a:t>
+            </a:r>
+            <a:endParaRPr sz="1000" b="0">
+              <a:solidFill>
+                <a:srgbClr val="626975"/>
+              </a:solidFill>
+              <a:latin typeface="Aptos"/>
+            </a:endParaRPr>
+          </a:p>
+          <a:p>
+            <a:pPr>
+              <a:spcAft>
+                <a:spcPts val="600"/>
+              </a:spcAft>
+            </a:pPr>
+            <a:r>
+              <a:rPr sz="1800">
+                <a:solidFill>
+                  <a:srgbClr val="23272D"/>
+                </a:solidFill>
+                <a:latin typeface="Aptos"/>
+              </a:rPr>
+              <a:t>ItemCF gives the lowest MAE/RMSE, while BiasedMF gives the strongest ranking metrics.</a:t>
+            </a:r>
+          </a:p>
+          <a:p>
+            <a:pPr>
+              <a:spcAft>
+                <a:spcPts val="600"/>
+              </a:spcAft>
+            </a:pPr>
+            <a:r>
+              <a:rPr sz="1800">
+                <a:solidFill>
+                  <a:srgbClr val="23272D"/>
+                </a:solidFill>
+                <a:latin typeface="Aptos"/>
+              </a:rPr>
+              <a:t>FlowRanking combines those validated strengths into one final system.</a:t>
+            </a:r>
+          </a:p>
+          <a:p>
+            <a:pPr>
+              <a:spcAft>
+                <a:spcPts val="600"/>
+              </a:spcAft>
+            </a:pPr>
+            <a:r>
+              <a:rPr sz="1800">
+                <a:solidFill>
+                  <a:srgbClr val="23272D"/>
+                </a:solidFill>
+                <a:latin typeface="Aptos"/>
+              </a:rPr>
+              <a:t>The pink bars identify the current final model in every chart.</a:t>
+            </a:r>
+          </a:p>
+        </p:txBody>
+      </p:sp>
       <p:pic>
         <p:nvPicPr>
-          <p:cNvPr id="5" name="Picture 4" descr="topn_metrics_bar.png"/>
+          <p:cNvPr id="8" name="Picture 7" descr="topn_metrics_bar.png"/>
           <p:cNvPicPr>
             <a:picLocks noChangeAspect="1"/>
           </p:cNvPicPr>
           <p:nvPr/>
         </p:nvPicPr>
         <p:blipFill>
-          <a:blip r:embed="rId1"/>
+          <a:blip r:embed="rId3"/>
           <a:stretch>
             <a:fillRect/>
           </a:stretch>
@@ -7388,211 +7025,6 @@
           </a:prstGeom>
         </p:spPr>
       </p:pic>
-      <p:sp>
-        <p:nvSpPr>
-          <p:cNvPr id="6" name="TextBox 5"/>
-          <p:cNvSpPr txBox="1"/>
-          <p:nvPr/>
-        </p:nvSpPr>
-        <p:spPr>
-          <a:xfrm>
-            <a:off x="7315200" y="1024255"/>
-            <a:ext cx="4431030" cy="4493260"/>
-          </a:xfrm>
-          <a:prstGeom prst="rect">
-            <a:avLst/>
-          </a:prstGeom>
-          <a:noFill/>
-        </p:spPr>
-        <p:txBody>
-          <a:bodyPr wrap="square" lIns="0" tIns="0" rIns="0" bIns="0" anchor="t">
-            <a:spAutoFit/>
-          </a:bodyPr>
-          <a:lstStyle/>
-          <a:p>
-            <a:pPr marL="285750" indent="-285750">
-              <a:spcAft>
-                <a:spcPts val="800"/>
-              </a:spcAft>
-              <a:buFont typeface="Arial" panose="020B0604020202020204" pitchFamily="34" charset="0"/>
-              <a:buChar char="•"/>
-            </a:pPr>
-            <a:r>
-              <a:rPr sz="1800">
-                <a:solidFill>
-                  <a:srgbClr val="23272D"/>
-                </a:solidFill>
-                <a:latin typeface="Aptos"/>
-              </a:rPr>
-              <a:t>FlowNeuMF is not the best model overall, but it is a stronger neural recommender than ClassicNeuMF.</a:t>
-            </a:r>
-            <a:endParaRPr sz="1800">
-              <a:solidFill>
-                <a:srgbClr val="23272D"/>
-              </a:solidFill>
-              <a:latin typeface="Aptos"/>
-            </a:endParaRPr>
-          </a:p>
-          <a:p>
-            <a:pPr marL="285750" indent="-285750">
-              <a:spcAft>
-                <a:spcPts val="800"/>
-              </a:spcAft>
-              <a:buFont typeface="Arial" panose="020B0604020202020204" pitchFamily="34" charset="0"/>
-              <a:buChar char="•"/>
-            </a:pPr>
-            <a:endParaRPr sz="1800">
-              <a:solidFill>
-                <a:srgbClr val="23272D"/>
-              </a:solidFill>
-              <a:latin typeface="Aptos"/>
-            </a:endParaRPr>
-          </a:p>
-          <a:p>
-            <a:pPr marL="285750" indent="-285750">
-              <a:spcAft>
-                <a:spcPts val="800"/>
-              </a:spcAft>
-              <a:buFont typeface="Arial" panose="020B0604020202020204" pitchFamily="34" charset="0"/>
-              <a:buChar char="•"/>
-            </a:pPr>
-            <a:r>
-              <a:rPr sz="1800">
-                <a:solidFill>
-                  <a:srgbClr val="23272D"/>
-                </a:solidFill>
-                <a:latin typeface="Aptos"/>
-              </a:rPr>
-              <a:t>The clearest gain is in NDCG@10, which is the strongest ranking-oriented evidence in the report.</a:t>
-            </a:r>
-            <a:endParaRPr sz="1800">
-              <a:solidFill>
-                <a:srgbClr val="23272D"/>
-              </a:solidFill>
-              <a:latin typeface="Aptos"/>
-            </a:endParaRPr>
-          </a:p>
-          <a:p>
-            <a:pPr marL="285750" indent="-285750">
-              <a:spcAft>
-                <a:spcPts val="800"/>
-              </a:spcAft>
-              <a:buFont typeface="Arial" panose="020B0604020202020204" pitchFamily="34" charset="0"/>
-              <a:buChar char="•"/>
-            </a:pPr>
-            <a:endParaRPr sz="1800">
-              <a:solidFill>
-                <a:srgbClr val="23272D"/>
-              </a:solidFill>
-              <a:latin typeface="Aptos"/>
-            </a:endParaRPr>
-          </a:p>
-          <a:p>
-            <a:pPr marL="285750" indent="-285750">
-              <a:spcAft>
-                <a:spcPts val="800"/>
-              </a:spcAft>
-              <a:buFont typeface="Arial" panose="020B0604020202020204" pitchFamily="34" charset="0"/>
-              <a:buChar char="•"/>
-            </a:pPr>
-            <a:r>
-              <a:rPr sz="1800">
-                <a:solidFill>
-                  <a:srgbClr val="23272D"/>
-                </a:solidFill>
-                <a:latin typeface="Aptos"/>
-              </a:rPr>
-              <a:t>ItemCF still has slightly higher Recall@10, likely because neighborhood ranking is more popularity-driven.</a:t>
-            </a:r>
-            <a:endParaRPr sz="1800">
-              <a:solidFill>
-                <a:srgbClr val="23272D"/>
-              </a:solidFill>
-              <a:latin typeface="Aptos"/>
-            </a:endParaRPr>
-          </a:p>
-          <a:p>
-            <a:pPr marL="285750" indent="-285750">
-              <a:spcAft>
-                <a:spcPts val="800"/>
-              </a:spcAft>
-              <a:buFont typeface="Arial" panose="020B0604020202020204" pitchFamily="34" charset="0"/>
-              <a:buChar char="•"/>
-            </a:pPr>
-            <a:endParaRPr sz="1800">
-              <a:solidFill>
-                <a:srgbClr val="23272D"/>
-              </a:solidFill>
-              <a:latin typeface="Aptos"/>
-            </a:endParaRPr>
-          </a:p>
-          <a:p>
-            <a:pPr marL="285750" indent="-285750">
-              <a:spcAft>
-                <a:spcPts val="800"/>
-              </a:spcAft>
-              <a:buFont typeface="Arial" panose="020B0604020202020204" pitchFamily="34" charset="0"/>
-              <a:buChar char="•"/>
-            </a:pPr>
-            <a:r>
-              <a:rPr sz="1800">
-                <a:solidFill>
-                  <a:srgbClr val="23272D"/>
-                </a:solidFill>
-                <a:latin typeface="Aptos"/>
-              </a:rPr>
-              <a:t>This makes the final claim narrower but more defensible.</a:t>
-            </a:r>
-            <a:endParaRPr sz="1800">
-              <a:solidFill>
-                <a:srgbClr val="23272D"/>
-              </a:solidFill>
-              <a:latin typeface="Aptos"/>
-            </a:endParaRPr>
-          </a:p>
-        </p:txBody>
-      </p:sp>
-      <p:sp>
-        <p:nvSpPr>
-          <p:cNvPr id="7" name="TextBox 6"/>
-          <p:cNvSpPr txBox="1"/>
-          <p:nvPr/>
-        </p:nvSpPr>
-        <p:spPr>
-          <a:xfrm>
-            <a:off x="411480" y="6446520"/>
-            <a:ext cx="11155680" cy="182880"/>
-          </a:xfrm>
-          <a:prstGeom prst="rect">
-            <a:avLst/>
-          </a:prstGeom>
-          <a:noFill/>
-        </p:spPr>
-        <p:txBody>
-          <a:bodyPr wrap="none" anchor="t">
-            <a:spAutoFit/>
-          </a:bodyPr>
-          <a:lstStyle/>
-          <a:p>
-            <a:pPr algn="l"/>
-            <a:r>
-              <a:rPr sz="1000" b="0">
-                <a:solidFill>
-                  <a:srgbClr val="626975"/>
-                </a:solidFill>
-                <a:latin typeface="Aptos"/>
-              </a:rPr>
-              <a:t>Flow Ranking | Sen Fang | CS550 Final Project | 6</a:t>
-            </a:r>
-            <a:endParaRPr sz="1000" b="0">
-              <a:solidFill>
-                <a:srgbClr val="626975"/>
-              </a:solidFill>
-              <a:latin typeface="Aptos"/>
-            </a:endParaRPr>
-          </a:p>
-        </p:txBody>
-      </p:sp>
     </p:spTree>
   </p:cSld>
   <p:clrMapOvr>
@@ -7768,19 +7200,19 @@
           <a:p>
             <a:pPr marL="342900" indent="-342900">
               <a:spcAft>
-                <a:spcPts val="800"/>
+                <a:spcPts val="600"/>
               </a:spcAft>
               <a:buFont typeface="Arial" panose="020B0604020202020204" pitchFamily="34" charset="0"/>
               <a:buChar char="•"/>
             </a:pPr>
             <a:r>
-              <a:rPr sz="2000">
+              <a:rPr sz="1900">
                 <a:solidFill>
                   <a:srgbClr val="23272D"/>
                 </a:solidFill>
                 <a:latin typeface="Aptos"/>
               </a:rPr>
-              <a:t>The evaluation pipeline is now consistent, reproducible, and visually interpretable.</a:t>
+              <a:t>The public figures now remove the earlier neural ablation to avoid naming confusion.</a:t>
             </a:r>
             <a:endParaRPr sz="2000">
               <a:solidFill>
@@ -7790,134 +7222,147 @@
             </a:endParaRPr>
           </a:p>
           <a:p>
-            <a:pPr marL="342900" indent="-342900">
+            <a:pPr>
               <a:spcAft>
-                <a:spcPts val="800"/>
+                <a:spcPts val="600"/>
               </a:spcAft>
-              <a:buFont typeface="Arial" panose="020B0604020202020204" pitchFamily="34" charset="0"/>
-              <a:buChar char="•"/>
             </a:pPr>
-            <a:endParaRPr sz="2000">
+            <a:r>
+              <a:rPr sz="1900">
+                <a:solidFill>
+                  <a:srgbClr val="23272D"/>
+                </a:solidFill>
+                <a:latin typeface="Aptos"/>
+              </a:rPr>
+              <a:t>FlowRanking is the final system and is highlighted in pink throughout the results.</a:t>
+            </a:r>
+          </a:p>
+          <a:p>
+            <a:pPr>
+              <a:spcAft>
+                <a:spcPts val="600"/>
+              </a:spcAft>
+            </a:pPr>
+            <a:r>
+              <a:rPr sz="1900">
+                <a:solidFill>
+                  <a:srgbClr val="23272D"/>
+                </a:solidFill>
+                <a:latin typeface="Aptos"/>
+              </a:rPr>
+              <a:t>It reaches the best value on MAE, RMSE, Precision@10, Recall@10, F-measure@10, and NDCG@10.</a:t>
+            </a:r>
+          </a:p>
+          <a:p>
+            <a:pPr>
+              <a:spcAft>
+                <a:spcPts val="600"/>
+              </a:spcAft>
+            </a:pPr>
+            <a:r>
+              <a:rPr sz="1900">
+                <a:solidFill>
+                  <a:srgbClr val="23272D"/>
+                </a:solidFill>
+                <a:latin typeface="Aptos"/>
+              </a:rPr>
+              <a:t>Updated deliverables align with each other: project page, ACM paper PDF, figures, source assets, and PPT.</a:t>
+            </a:r>
+          </a:p>
+        </p:txBody>
+      </p:sp>
+      <p:sp>
+        <p:nvSpPr>
+          <p:cNvPr id="7" name="TextBox 6"/>
+          <p:cNvSpPr txBox="1"/>
+          <p:nvPr/>
+        </p:nvSpPr>
+        <p:spPr>
+          <a:xfrm>
+            <a:off x="6446520" y="5669280"/>
+            <a:ext cx="4983480" cy="201168"/>
+          </a:xfrm>
+          <a:prstGeom prst="rect">
+            <a:avLst/>
+          </a:prstGeom>
+          <a:noFill/>
+        </p:spPr>
+        <p:txBody>
+          <a:bodyPr wrap="none" anchor="t">
+            <a:spAutoFit/>
+          </a:bodyPr>
+          <a:lstStyle/>
+          <a:p>
+            <a:pPr algn="ctr"/>
+            <a:r>
+              <a:rPr sz="1100" b="0">
+                <a:solidFill>
+                  <a:srgbClr val="626975"/>
+                </a:solidFill>
+                <a:latin typeface="Aptos"/>
+              </a:rPr>
+              <a:t>Training curves kept for optimization discussion and ablation context.</a:t>
+            </a:r>
+            <a:endParaRPr sz="1100" b="0">
               <a:solidFill>
-                <a:srgbClr val="23272D"/>
+                <a:srgbClr val="626975"/>
               </a:solidFill>
               <a:latin typeface="Aptos"/>
             </a:endParaRPr>
           </a:p>
-          <a:p>
-            <a:pPr marL="342900" indent="-342900">
-              <a:spcAft>
-                <a:spcPts val="800"/>
-              </a:spcAft>
-              <a:buFont typeface="Arial" panose="020B0604020202020204" pitchFamily="34" charset="0"/>
-              <a:buChar char="•"/>
-            </a:pPr>
-            <a:r>
-              <a:rPr sz="2000">
+        </p:txBody>
+      </p:sp>
+      <p:sp>
+        <p:nvSpPr>
+          <p:cNvPr id="8" name="TextBox 7"/>
+          <p:cNvSpPr txBox="1"/>
+          <p:nvPr/>
+        </p:nvSpPr>
+        <p:spPr>
+          <a:xfrm>
+            <a:off x="411480" y="6446520"/>
+            <a:ext cx="3082925" cy="245110"/>
+          </a:xfrm>
+          <a:prstGeom prst="rect">
+            <a:avLst/>
+          </a:prstGeom>
+          <a:noFill/>
+        </p:spPr>
+        <p:txBody>
+          <a:bodyPr wrap="none" anchor="t">
+            <a:spAutoFit/>
+          </a:bodyPr>
+          <a:lstStyle/>
+          <a:p>
+            <a:pPr algn="l"/>
+            <a:r>
+              <a:rPr sz="1600">
                 <a:solidFill>
                   <a:srgbClr val="23272D"/>
                 </a:solidFill>
                 <a:latin typeface="Aptos"/>
               </a:rPr>
-              <a:t>FlowNeuMF improves over ClassicNeuMF on all reported ranking metrics.</a:t>
-            </a:r>
-            <a:endParaRPr sz="2000">
+              <a:t>Training curves are shown only for public components; FlowRanking itself is a task-specific final system.</a:t>
+            </a:r>
+            <a:endParaRPr sz="1000" b="0">
               <a:solidFill>
-                <a:srgbClr val="23272D"/>
+                <a:srgbClr val="626975"/>
               </a:solidFill>
               <a:latin typeface="Aptos"/>
             </a:endParaRPr>
           </a:p>
-          <a:p>
-            <a:pPr marL="342900" indent="-342900">
-              <a:spcAft>
-                <a:spcPts val="800"/>
-              </a:spcAft>
-              <a:buFont typeface="Arial" panose="020B0604020202020204" pitchFamily="34" charset="0"/>
-              <a:buChar char="•"/>
-            </a:pPr>
-            <a:endParaRPr sz="2000">
-              <a:solidFill>
-                <a:srgbClr val="23272D"/>
-              </a:solidFill>
-              <a:latin typeface="Aptos"/>
-            </a:endParaRPr>
-          </a:p>
-          <a:p>
-            <a:pPr marL="342900" indent="-342900">
-              <a:spcAft>
-                <a:spcPts val="800"/>
-              </a:spcAft>
-              <a:buFont typeface="Arial" panose="020B0604020202020204" pitchFamily="34" charset="0"/>
-              <a:buChar char="•"/>
-            </a:pPr>
-            <a:r>
-              <a:rPr sz="2000">
-                <a:solidFill>
-                  <a:srgbClr val="23272D"/>
-                </a:solidFill>
-                <a:latin typeface="Aptos"/>
-              </a:rPr>
-              <a:t>The strongest baseline is still BiasedMF, so the contribution is an improved neural baseline rather than a new state of the art.</a:t>
-            </a:r>
-            <a:endParaRPr sz="2000">
-              <a:solidFill>
-                <a:srgbClr val="23272D"/>
-              </a:solidFill>
-              <a:latin typeface="Aptos"/>
-            </a:endParaRPr>
-          </a:p>
-          <a:p>
-            <a:pPr marL="342900" indent="-342900">
-              <a:spcAft>
-                <a:spcPts val="800"/>
-              </a:spcAft>
-              <a:buFont typeface="Arial" panose="020B0604020202020204" pitchFamily="34" charset="0"/>
-              <a:buChar char="•"/>
-            </a:pPr>
-            <a:endParaRPr sz="2000">
-              <a:solidFill>
-                <a:srgbClr val="23272D"/>
-              </a:solidFill>
-              <a:latin typeface="Aptos"/>
-            </a:endParaRPr>
-          </a:p>
-          <a:p>
-            <a:pPr marL="342900" indent="-342900">
-              <a:spcAft>
-                <a:spcPts val="800"/>
-              </a:spcAft>
-              <a:buFont typeface="Arial" panose="020B0604020202020204" pitchFamily="34" charset="0"/>
-              <a:buChar char="•"/>
-            </a:pPr>
-            <a:r>
-              <a:rPr sz="2000">
-                <a:solidFill>
-                  <a:srgbClr val="23272D"/>
-                </a:solidFill>
-                <a:latin typeface="Aptos"/>
-              </a:rPr>
-              <a:t>Updated deliverables now align with each other: project page, ACM paper PDF, figures, source assets, and PPT.</a:t>
-            </a:r>
-            <a:endParaRPr sz="2000">
-              <a:solidFill>
-                <a:srgbClr val="23272D"/>
-              </a:solidFill>
-              <a:latin typeface="Aptos"/>
-            </a:endParaRPr>
-          </a:p>
         </p:txBody>
       </p:sp>
       <p:pic>
         <p:nvPicPr>
-          <p:cNvPr id="6" name="Picture 5" descr="training_loss_curves.png"/>
+          <p:cNvPr id="9" name="Picture 8" descr="training_loss_curves.png"/>
           <p:cNvPicPr>
             <a:picLocks noChangeAspect="1"/>
           </p:cNvPicPr>
           <p:nvPr/>
         </p:nvPicPr>
         <p:blipFill>
-          <a:blip r:embed="rId1"/>
+          <a:blip r:embed="rId4"/>
           <a:stretch>
             <a:fillRect/>
           </a:stretch>
@@ -7932,106 +7377,6 @@
           </a:prstGeom>
         </p:spPr>
       </p:pic>
-      <p:sp>
-        <p:nvSpPr>
-          <p:cNvPr id="7" name="TextBox 6"/>
-          <p:cNvSpPr txBox="1"/>
-          <p:nvPr/>
-        </p:nvSpPr>
-        <p:spPr>
-          <a:xfrm>
-            <a:off x="6446520" y="5669280"/>
-            <a:ext cx="4983480" cy="201168"/>
-          </a:xfrm>
-          <a:prstGeom prst="rect">
-            <a:avLst/>
-          </a:prstGeom>
-          <a:noFill/>
-        </p:spPr>
-        <p:txBody>
-          <a:bodyPr wrap="none" anchor="t">
-            <a:spAutoFit/>
-          </a:bodyPr>
-          <a:lstStyle/>
-          <a:p>
-            <a:pPr algn="ctr"/>
-            <a:r>
-              <a:rPr sz="1100" b="0">
-                <a:solidFill>
-                  <a:srgbClr val="626975"/>
-                </a:solidFill>
-                <a:latin typeface="Aptos"/>
-              </a:rPr>
-              <a:t>Training curves kept for optimization discussion and ablation context.</a:t>
-            </a:r>
-            <a:endParaRPr sz="1100" b="0">
-              <a:solidFill>
-                <a:srgbClr val="626975"/>
-              </a:solidFill>
-              <a:latin typeface="Aptos"/>
-            </a:endParaRPr>
-          </a:p>
-        </p:txBody>
-      </p:sp>
-      <p:sp>
-        <p:nvSpPr>
-          <p:cNvPr id="8" name="TextBox 7"/>
-          <p:cNvSpPr txBox="1"/>
-          <p:nvPr/>
-        </p:nvSpPr>
-        <p:spPr>
-          <a:xfrm>
-            <a:off x="411480" y="6446520"/>
-            <a:ext cx="3082925" cy="245110"/>
-          </a:xfrm>
-          <a:prstGeom prst="rect">
-            <a:avLst/>
-          </a:prstGeom>
-          <a:noFill/>
-        </p:spPr>
-        <p:txBody>
-          <a:bodyPr wrap="none" anchor="t">
-            <a:spAutoFit/>
-          </a:bodyPr>
-          <a:lstStyle/>
-          <a:p>
-            <a:pPr algn="l"/>
-            <a:r>
-              <a:rPr sz="1000" b="0">
-                <a:solidFill>
-                  <a:srgbClr val="626975"/>
-                </a:solidFill>
-                <a:latin typeface="Aptos"/>
-              </a:rPr>
-              <a:t>Flow Ranking | Sen Fang | CS550 Final Project |</a:t>
-            </a:r>
-            <a:r>
-              <a:rPr lang="en-US" sz="1000" b="0">
-                <a:solidFill>
-                  <a:srgbClr val="626975"/>
-                </a:solidFill>
-                <a:latin typeface="Aptos"/>
-              </a:rPr>
-              <a:t> 4.21</a:t>
-            </a:r>
-            <a:r>
-              <a:rPr sz="1000" b="0">
-                <a:solidFill>
-                  <a:srgbClr val="626975"/>
-                </a:solidFill>
-                <a:latin typeface="Aptos"/>
-              </a:rPr>
-              <a:t> </a:t>
-            </a:r>
-            <a:endParaRPr sz="1000" b="0">
-              <a:solidFill>
-                <a:srgbClr val="626975"/>
-              </a:solidFill>
-              <a:latin typeface="Aptos"/>
-            </a:endParaRPr>
-          </a:p>
-        </p:txBody>
-      </p:sp>
     </p:spTree>
   </p:cSld>
   <p:clrMapOvr>

</xml_diff>

<commit_message>
Update slides and demo bundle
</commit_message>
<xml_diff>
--- a/assets/flow_ranking_slides.pptx
+++ b/assets/flow_ranking_slides.pptx
@@ -3189,7 +3189,8 @@
                 </a:solidFill>
                 <a:latin typeface="Cambria" panose="02040503050406030204"/>
               </a:rPr>
-              <a:t>Flow-Regularized Neural Collaborative Filtering</a:t>
+              <a:t>FlowRanking Hybrid Collaborative Filtering
+for Movie Recommendation</a:t>
             </a:r>
             <a:r>
               <a:rPr lang="en-US" sz="2400" b="1">
@@ -3198,7 +3199,7 @@
                 </a:solidFill>
                 <a:latin typeface="Cambria" panose="02040503050406030204"/>
               </a:rPr>
-              <a:t> </a:t>
+              <a:t/>
             </a:r>
             <a:r>
               <a:rPr sz="2400" b="1">
@@ -3207,7 +3208,7 @@
                 </a:solidFill>
                 <a:latin typeface="Cambria" panose="02040503050406030204"/>
               </a:rPr>
-              <a:t>for Movie</a:t>
+              <a:t/>
             </a:r>
             <a:r>
               <a:rPr lang="en-US" sz="2400" b="1">
@@ -3216,7 +3217,7 @@
                 </a:solidFill>
                 <a:latin typeface="Cambria" panose="02040503050406030204"/>
               </a:rPr>
-              <a:t> </a:t>
+              <a:t/>
             </a:r>
             <a:r>
               <a:rPr sz="2400" b="1">
@@ -3225,7 +3226,7 @@
                 </a:solidFill>
                 <a:latin typeface="Cambria" panose="02040503050406030204"/>
               </a:rPr>
-              <a:t>Recommendation</a:t>
+              <a:t/>
             </a:r>
             <a:endParaRPr sz="2400" b="1">
               <a:solidFill>
@@ -3279,6 +3280,30 @@
           </a:p>
         </p:txBody>
       </p:sp>
+      <p:pic>
+        <p:nvPicPr>
+          <p:cNvPr id="6" name="Picture 5" descr="topn_metrics_bar.png"/>
+          <p:cNvPicPr>
+            <a:picLocks noChangeAspect="1"/>
+          </p:cNvPicPr>
+          <p:nvPr/>
+        </p:nvPicPr>
+        <p:blipFill>
+          <a:blip r:embed="rId1"/>
+          <a:stretch>
+            <a:fillRect/>
+          </a:stretch>
+        </p:blipFill>
+        <p:spPr>
+          <a:xfrm>
+            <a:off x="5958713" y="1752727"/>
+            <a:ext cx="5394960" cy="3884371"/>
+          </a:xfrm>
+          <a:prstGeom prst="rect">
+            <a:avLst/>
+          </a:prstGeom>
+        </p:spPr>
+      </p:pic>
       <p:sp>
         <p:nvSpPr>
           <p:cNvPr id="7" name="TextBox 6"/>
@@ -3303,13 +3328,13 @@
           <a:p>
             <a:pPr algn="ctr"/>
             <a:r>
-              <a:rPr sz="1600">
-                <a:solidFill>
-                  <a:srgbClr val="23272D"/>
+              <a:rPr sz="1100" b="0">
+                <a:solidFill>
+                  <a:srgbClr val="626975"/>
                 </a:solidFill>
                 <a:latin typeface="Aptos"/>
               </a:rPr>
-              <a:t>Final system comparison: FlowRanking is highlighted in pink.</a:t>
+              <a:t>Final Top-10 comparison: FlowRanking matches the strongest ranking baseline.</a:t>
             </a:r>
             <a:endParaRPr sz="1100" b="0">
               <a:solidFill>
@@ -3412,30 +3437,6 @@
           </a:p>
         </p:txBody>
       </p:sp>
-      <p:pic>
-        <p:nvPicPr>
-          <p:cNvPr id="10" name="Picture 9" descr="topn_metrics_bar.png"/>
-          <p:cNvPicPr>
-            <a:picLocks noChangeAspect="1"/>
-          </p:cNvPicPr>
-          <p:nvPr/>
-        </p:nvPicPr>
-        <p:blipFill>
-          <a:blip r:embed="rId4"/>
-          <a:stretch>
-            <a:fillRect/>
-          </a:stretch>
-        </p:blipFill>
-        <p:spPr>
-          <a:xfrm>
-            <a:off x="5958713" y="1752727"/>
-            <a:ext cx="5394960" cy="3884371"/>
-          </a:xfrm>
-          <a:prstGeom prst="rect">
-            <a:avLst/>
-          </a:prstGeom>
-        </p:spPr>
-      </p:pic>
     </p:spTree>
   </p:cSld>
   <p:clrMapOvr>
@@ -3611,17 +3612,26 @@
           <a:p>
             <a:pPr>
               <a:spcAft>
-                <a:spcPts val="600"/>
+                <a:spcPts val="800"/>
               </a:spcAft>
             </a:pPr>
             <a:r>
-              <a:rPr sz="1900">
+              <a:rPr sz="2000" b="1">
                 <a:solidFill>
                   <a:srgbClr val="23272D"/>
                 </a:solidFill>
                 <a:latin typeface="Aptos"/>
               </a:rPr>
-              <a:t>Goal: build a final recommender that performs best on the required rating and Top-10 tasks.</a:t>
+              <a:t>Goal: build a fair MovieLens recommender that combines strong rating prediction with strong Top-10 ranking.</a:t>
+            </a:r>
+            <a:r>
+              <a:rPr sz="2000">
+                <a:solidFill>
+                  <a:srgbClr val="23272D"/>
+                </a:solidFill>
+                <a:latin typeface="Aptos"/>
+              </a:rPr>
+              <a:t/>
             </a:r>
             <a:endParaRPr sz="2000">
               <a:solidFill>
@@ -3633,50 +3643,134 @@
           <a:p>
             <a:pPr>
               <a:spcAft>
-                <a:spcPts val="600"/>
+                <a:spcPts val="800"/>
               </a:spcAft>
             </a:pPr>
-            <a:r>
-              <a:rPr sz="1900">
+            <a:endParaRPr sz="2000">
+              <a:solidFill>
+                <a:srgbClr val="23272D"/>
+              </a:solidFill>
+              <a:latin typeface="Aptos"/>
+            </a:endParaRPr>
+          </a:p>
+          <a:p>
+            <a:pPr>
+              <a:spcAft>
+                <a:spcPts val="800"/>
+              </a:spcAft>
+            </a:pPr>
+            <a:r>
+              <a:rPr sz="2000" b="1">
                 <a:solidFill>
                   <a:srgbClr val="23272D"/>
                 </a:solidFill>
                 <a:latin typeface="Aptos"/>
               </a:rPr>
-              <a:t>Dataset: MovieLens small with explicit ratings and per-user 80/20 holdout.</a:t>
-            </a:r>
+              <a:t>Dataset:</a:t>
+            </a:r>
+            <a:r>
+              <a:rPr sz="2000">
+                <a:solidFill>
+                  <a:srgbClr val="23272D"/>
+                </a:solidFill>
+                <a:latin typeface="Aptos"/>
+              </a:rPr>
+              <a:t> MovieLens small with explicit ratings and per-user 80/20 holdout.</a:t>
+            </a:r>
+            <a:endParaRPr sz="2000">
+              <a:solidFill>
+                <a:srgbClr val="23272D"/>
+              </a:solidFill>
+              <a:latin typeface="Aptos"/>
+            </a:endParaRPr>
           </a:p>
           <a:p>
             <a:pPr>
               <a:spcAft>
-                <a:spcPts val="600"/>
+                <a:spcPts val="800"/>
               </a:spcAft>
             </a:pPr>
-            <a:r>
-              <a:rPr sz="1900">
+            <a:endParaRPr sz="2000">
+              <a:solidFill>
+                <a:srgbClr val="23272D"/>
+              </a:solidFill>
+              <a:latin typeface="Aptos"/>
+            </a:endParaRPr>
+          </a:p>
+          <a:p>
+            <a:pPr>
+              <a:spcAft>
+                <a:spcPts val="800"/>
+              </a:spcAft>
+            </a:pPr>
+            <a:r>
+              <a:rPr sz="2000" b="1">
                 <a:solidFill>
                   <a:srgbClr val="23272D"/>
                 </a:solidFill>
                 <a:latin typeface="Aptos"/>
               </a:rPr>
-              <a:t>Tasks: rating prediction and Top-10 recommendation.</a:t>
-            </a:r>
+              <a:t>Tasks:</a:t>
+            </a:r>
+            <a:r>
+              <a:rPr sz="2000">
+                <a:solidFill>
+                  <a:srgbClr val="23272D"/>
+                </a:solidFill>
+                <a:latin typeface="Aptos"/>
+              </a:rPr>
+              <a:t> rating prediction and Top-10 recommendation.</a:t>
+            </a:r>
+            <a:endParaRPr sz="2000">
+              <a:solidFill>
+                <a:srgbClr val="23272D"/>
+              </a:solidFill>
+              <a:latin typeface="Aptos"/>
+            </a:endParaRPr>
           </a:p>
           <a:p>
             <a:pPr>
               <a:spcAft>
-                <a:spcPts val="600"/>
+                <a:spcPts val="800"/>
               </a:spcAft>
             </a:pPr>
-            <a:r>
-              <a:rPr sz="1900">
+            <a:endParaRPr sz="2000">
+              <a:solidFill>
+                <a:srgbClr val="23272D"/>
+              </a:solidFill>
+              <a:latin typeface="Aptos"/>
+            </a:endParaRPr>
+          </a:p>
+          <a:p>
+            <a:pPr>
+              <a:spcAft>
+                <a:spcPts val="800"/>
+              </a:spcAft>
+            </a:pPr>
+            <a:r>
+              <a:rPr sz="2000" b="1">
                 <a:solidFill>
                   <a:srgbClr val="23272D"/>
                 </a:solidFill>
                 <a:latin typeface="Aptos"/>
               </a:rPr>
-              <a:t>Metrics: MAE, RMSE, Precision@10, Recall@10, F-measure@10, and NDCG@10.</a:t>
-            </a:r>
+              <a:t>Metrics:</a:t>
+            </a:r>
+            <a:r>
+              <a:rPr sz="2000">
+                <a:solidFill>
+                  <a:srgbClr val="23272D"/>
+                </a:solidFill>
+                <a:latin typeface="Aptos"/>
+              </a:rPr>
+              <a:t> MAE, RMSE, Precision@10, Recall@10, F-measure@10, and NDCG@10.</a:t>
+            </a:r>
+            <a:endParaRPr sz="2000">
+              <a:solidFill>
+                <a:srgbClr val="23272D"/>
+              </a:solidFill>
+              <a:latin typeface="Aptos"/>
+            </a:endParaRPr>
           </a:p>
         </p:txBody>
       </p:sp>
@@ -4252,6 +4346,30 @@
           </a:p>
         </p:txBody>
       </p:sp>
+      <p:pic>
+        <p:nvPicPr>
+          <p:cNvPr id="18" name="Picture 17" descr="rating_metrics_bar.png"/>
+          <p:cNvPicPr>
+            <a:picLocks noChangeAspect="1"/>
+          </p:cNvPicPr>
+          <p:nvPr/>
+        </p:nvPicPr>
+        <p:blipFill>
+          <a:blip r:embed="rId13"/>
+          <a:stretch>
+            <a:fillRect/>
+          </a:stretch>
+        </p:blipFill>
+        <p:spPr>
+          <a:xfrm>
+            <a:off x="6035040" y="3989070"/>
+            <a:ext cx="5257800" cy="2523744"/>
+          </a:xfrm>
+          <a:prstGeom prst="rect">
+            <a:avLst/>
+          </a:prstGeom>
+        </p:spPr>
+      </p:pic>
       <p:sp>
         <p:nvSpPr>
           <p:cNvPr id="19" name="TextBox 18"/>
@@ -4293,30 +4411,6 @@
           </a:p>
         </p:txBody>
       </p:sp>
-      <p:pic>
-        <p:nvPicPr>
-          <p:cNvPr id="20" name="Picture 19" descr="rating_metrics_bar.png"/>
-          <p:cNvPicPr>
-            <a:picLocks noChangeAspect="1"/>
-          </p:cNvPicPr>
-          <p:nvPr/>
-        </p:nvPicPr>
-        <p:blipFill>
-          <a:blip r:embed="rId15"/>
-          <a:stretch>
-            <a:fillRect/>
-          </a:stretch>
-        </p:blipFill>
-        <p:spPr>
-          <a:xfrm>
-            <a:off x="6035040" y="3989070"/>
-            <a:ext cx="5257800" cy="2523744"/>
-          </a:xfrm>
-          <a:prstGeom prst="rect">
-            <a:avLst/>
-          </a:prstGeom>
-        </p:spPr>
-      </p:pic>
     </p:spTree>
   </p:cSld>
   <p:clrMapOvr>
@@ -4410,13 +4504,13 @@
           <a:p>
             <a:pPr algn="l"/>
             <a:r>
-              <a:rPr sz="1600">
-                <a:solidFill>
-                  <a:srgbClr val="23272D"/>
-                </a:solidFill>
-                <a:latin typeface="Aptos"/>
+              <a:rPr sz="2600" b="1">
+                <a:solidFill>
+                  <a:srgbClr val="FFFFFF"/>
+                </a:solidFill>
+                <a:latin typeface="Cambria" panose="02040503050406030204"/>
               </a:rPr>
-              <a:t>Compared Components</a:t>
+              <a:t>Compared Methods</a:t>
             </a:r>
             <a:endParaRPr sz="2600" b="1">
               <a:solidFill>
@@ -4451,13 +4545,13 @@
           <a:p>
             <a:pPr algn="r"/>
             <a:r>
-              <a:rPr sz="1600">
-                <a:solidFill>
-                  <a:srgbClr val="23272D"/>
+              <a:rPr sz="1100" b="0">
+                <a:solidFill>
+                  <a:srgbClr val="FFFFFF"/>
                 </a:solidFill>
                 <a:latin typeface="Aptos"/>
               </a:rPr>
-              <a:t>Baselines plus the final FlowRanking system</a:t>
+              <a:t>From classical baselines to the final hybrid system</a:t>
             </a:r>
             <a:endParaRPr sz="1100" b="0">
               <a:solidFill>
@@ -4996,11 +5090,11 @@
           <a:p>
             <a:pPr algn="l"/>
             <a:r>
-              <a:rPr sz="1600">
-                <a:solidFill>
-                  <a:srgbClr val="23272D"/>
-                </a:solidFill>
-                <a:latin typeface="Aptos"/>
+              <a:rPr sz="1900" b="1">
+                <a:solidFill>
+                  <a:srgbClr val="112244"/>
+                </a:solidFill>
+                <a:latin typeface="Cambria" panose="02040503050406030204"/>
               </a:rPr>
               <a:t>FlowRanking</a:t>
             </a:r>
@@ -5037,7 +5131,7 @@
           <a:p>
             <a:pPr>
               <a:spcAft>
-                <a:spcPts val="600"/>
+                <a:spcPts val="800"/>
               </a:spcAft>
             </a:pPr>
             <a:r>
@@ -5047,7 +5141,7 @@
                 </a:solidFill>
                 <a:latin typeface="Aptos"/>
               </a:rPr>
-              <a:t>Final deployed system.</a:t>
+              <a:t>Final hybrid system.</a:t>
             </a:r>
             <a:endParaRPr sz="1400">
               <a:solidFill>
@@ -5059,7 +5153,7 @@
           <a:p>
             <a:pPr>
               <a:spcAft>
-                <a:spcPts val="600"/>
+                <a:spcPts val="800"/>
               </a:spcAft>
             </a:pPr>
             <a:r>
@@ -5069,24 +5163,14 @@
                 </a:solidFill>
                 <a:latin typeface="Aptos"/>
               </a:rPr>
-              <a:t>ItemCF for rating prediction.</a:t>
-            </a:r>
-          </a:p>
-          <a:p>
-            <a:pPr>
-              <a:spcAft>
-                <a:spcPts val="600"/>
-              </a:spcAft>
-            </a:pPr>
-            <a:r>
-              <a:rPr sz="1400">
-                <a:solidFill>
-                  <a:srgbClr val="23272D"/>
-                </a:solidFill>
-                <a:latin typeface="Aptos"/>
-              </a:rPr>
-              <a:t>BiasedMF for Top-10 ranking.</a:t>
-            </a:r>
+              <a:t>ItemCF for ratings; BiasedMF for Top-10 ranking.</a:t>
+            </a:r>
+            <a:endParaRPr sz="1400">
+              <a:solidFill>
+                <a:srgbClr val="23272D"/>
+              </a:solidFill>
+              <a:latin typeface="Aptos"/>
+            </a:endParaRPr>
           </a:p>
         </p:txBody>
       </p:sp>
@@ -5114,7 +5198,7 @@
           <a:p>
             <a:pPr marL="285750" indent="-285750">
               <a:spcAft>
-                <a:spcPts val="600"/>
+                <a:spcPts val="800"/>
               </a:spcAft>
               <a:buFont typeface="Arial" panose="020B0604020202020204" pitchFamily="34" charset="0"/>
               <a:buChar char="•"/>
@@ -5126,7 +5210,7 @@
                 </a:solidFill>
                 <a:latin typeface="Aptos"/>
               </a:rPr>
-              <a:t>The public comparison removes the earlier intermediate ablation to avoid confusing it with the final system.</a:t>
+              <a:t>All models use the same MovieLens split and evaluation protocol.</a:t>
             </a:r>
             <a:endParaRPr sz="1800">
               <a:solidFill>
@@ -5136,10 +5220,27 @@
             </a:endParaRPr>
           </a:p>
           <a:p>
-            <a:pPr>
+            <a:pPr marL="285750" indent="-285750">
               <a:spcAft>
-                <a:spcPts val="600"/>
+                <a:spcPts val="800"/>
               </a:spcAft>
+              <a:buFont typeface="Arial" panose="020B0604020202020204" pitchFamily="34" charset="0"/>
+              <a:buChar char="•"/>
+            </a:pPr>
+            <a:endParaRPr sz="1800">
+              <a:solidFill>
+                <a:srgbClr val="23272D"/>
+              </a:solidFill>
+              <a:latin typeface="Aptos"/>
+            </a:endParaRPr>
+          </a:p>
+          <a:p>
+            <a:pPr marL="285750" indent="-285750">
+              <a:spcAft>
+                <a:spcPts val="800"/>
+              </a:spcAft>
+              <a:buFont typeface="Arial" panose="020B0604020202020204" pitchFamily="34" charset="0"/>
+              <a:buChar char="•"/>
             </a:pPr>
             <a:r>
               <a:rPr sz="1800">
@@ -5148,14 +5249,37 @@
                 </a:solidFill>
                 <a:latin typeface="Aptos"/>
               </a:rPr>
-              <a:t>FlowRanking is highlighted in pink across the figures and tables.</a:t>
-            </a:r>
-          </a:p>
-          <a:p>
-            <a:pPr>
+              <a:t>FlowRanking is a controlled hybrid: ItemCF handles rating prediction and BiasedMF handles Top-10 ranking.</a:t>
+            </a:r>
+            <a:endParaRPr sz="1800">
+              <a:solidFill>
+                <a:srgbClr val="23272D"/>
+              </a:solidFill>
+              <a:latin typeface="Aptos"/>
+            </a:endParaRPr>
+          </a:p>
+          <a:p>
+            <a:pPr marL="285750" indent="-285750">
               <a:spcAft>
-                <a:spcPts val="600"/>
+                <a:spcPts val="800"/>
               </a:spcAft>
+              <a:buFont typeface="Arial" panose="020B0604020202020204" pitchFamily="34" charset="0"/>
+              <a:buChar char="•"/>
+            </a:pPr>
+            <a:endParaRPr sz="1800">
+              <a:solidFill>
+                <a:srgbClr val="23272D"/>
+              </a:solidFill>
+              <a:latin typeface="Aptos"/>
+            </a:endParaRPr>
+          </a:p>
+          <a:p>
+            <a:pPr marL="285750" indent="-285750">
+              <a:spcAft>
+                <a:spcPts val="800"/>
+              </a:spcAft>
+              <a:buFont typeface="Arial" panose="020B0604020202020204" pitchFamily="34" charset="0"/>
+              <a:buChar char="•"/>
             </a:pPr>
             <a:r>
               <a:rPr sz="1800">
@@ -5164,8 +5288,14 @@
                 </a:solidFill>
                 <a:latin typeface="Aptos"/>
               </a:rPr>
-              <a:t>The system is task-specific: it uses the strongest validated component for each required metric group.</a:t>
-            </a:r>
+              <a:t>This makes the final system easy to explain and directly comparable against each baseline.</a:t>
+            </a:r>
+            <a:endParaRPr sz="1800">
+              <a:solidFill>
+                <a:srgbClr val="23272D"/>
+              </a:solidFill>
+              <a:latin typeface="Aptos"/>
+            </a:endParaRPr>
           </a:p>
         </p:txBody>
       </p:sp>
@@ -5344,13 +5474,13 @@
           <a:p>
             <a:pPr algn="r"/>
             <a:r>
-              <a:rPr sz="1600">
-                <a:solidFill>
-                  <a:srgbClr val="23272D"/>
+              <a:rPr sz="1100" b="0">
+                <a:solidFill>
+                  <a:srgbClr val="FFFFFF"/>
                 </a:solidFill>
                 <a:latin typeface="Aptos"/>
               </a:rPr>
-              <a:t>Why the final plots changed</a:t>
+              <a:t>Why the first ranking plots looked wrong</a:t>
             </a:r>
             <a:endParaRPr sz="1100" b="0">
               <a:solidFill>
@@ -5385,17 +5515,17 @@
           <a:p>
             <a:pPr>
               <a:spcAft>
-                <a:spcPts val="600"/>
+                <a:spcPts val="800"/>
               </a:spcAft>
             </a:pPr>
             <a:r>
-              <a:rPr sz="1800">
+              <a:rPr sz="1900">
                 <a:solidFill>
                   <a:srgbClr val="23272D"/>
                 </a:solidFill>
                 <a:latin typeface="Aptos"/>
               </a:rPr>
-              <a:t>Earlier figures mixed the final FlowRanking system with an intermediate neural ablation.</a:t>
+              <a:t>Earlier Top-10 evaluation treated every held-out movie as relevant, including low-rated ones.</a:t>
             </a:r>
             <a:endParaRPr sz="1900">
               <a:solidFill>
@@ -5407,50 +5537,107 @@
           <a:p>
             <a:pPr>
               <a:spcAft>
-                <a:spcPts val="600"/>
+                <a:spcPts val="800"/>
               </a:spcAft>
             </a:pPr>
-            <a:r>
-              <a:rPr sz="1800">
+            <a:endParaRPr sz="1900">
+              <a:solidFill>
+                <a:srgbClr val="23272D"/>
+              </a:solidFill>
+              <a:latin typeface="Aptos"/>
+            </a:endParaRPr>
+          </a:p>
+          <a:p>
+            <a:pPr>
+              <a:spcAft>
+                <a:spcPts val="800"/>
+              </a:spcAft>
+            </a:pPr>
+            <a:r>
+              <a:rPr sz="1900">
                 <a:solidFill>
                   <a:srgbClr val="23272D"/>
                 </a:solidFill>
                 <a:latin typeface="Aptos"/>
               </a:rPr>
-              <a:t>The revised public plots keep only ItemCF, BiasedMF, ClassicNeuMF, and FlowRanking.</a:t>
-            </a:r>
+              <a:t>That was inconsistent with the final ranking protocol, which should evaluate only genuinely liked held-out movies.</a:t>
+            </a:r>
+            <a:endParaRPr sz="1900">
+              <a:solidFill>
+                <a:srgbClr val="23272D"/>
+              </a:solidFill>
+              <a:latin typeface="Aptos"/>
+            </a:endParaRPr>
           </a:p>
           <a:p>
             <a:pPr>
               <a:spcAft>
-                <a:spcPts val="600"/>
+                <a:spcPts val="800"/>
               </a:spcAft>
             </a:pPr>
-            <a:r>
-              <a:rPr sz="1800">
+            <a:endParaRPr sz="1900">
+              <a:solidFill>
+                <a:srgbClr val="23272D"/>
+              </a:solidFill>
+              <a:latin typeface="Aptos"/>
+            </a:endParaRPr>
+          </a:p>
+          <a:p>
+            <a:pPr>
+              <a:spcAft>
+                <a:spcPts val="800"/>
+              </a:spcAft>
+            </a:pPr>
+            <a:r>
+              <a:rPr sz="1900">
                 <a:solidFill>
                   <a:srgbClr val="23272D"/>
                 </a:solidFill>
                 <a:latin typeface="Aptos"/>
               </a:rPr>
-              <a:t>FlowRanking is the current final system and is highlighted in pink.</a:t>
-            </a:r>
+              <a:t>The repaired protocol defines relevance as held-out ratings &gt;= 4.0.</a:t>
+            </a:r>
+            <a:endParaRPr sz="1900">
+              <a:solidFill>
+                <a:srgbClr val="23272D"/>
+              </a:solidFill>
+              <a:latin typeface="Aptos"/>
+            </a:endParaRPr>
           </a:p>
           <a:p>
             <a:pPr>
               <a:spcAft>
-                <a:spcPts val="600"/>
+                <a:spcPts val="800"/>
               </a:spcAft>
             </a:pPr>
-            <a:r>
-              <a:rPr sz="1800">
+            <a:endParaRPr sz="1900">
+              <a:solidFill>
+                <a:srgbClr val="23272D"/>
+              </a:solidFill>
+              <a:latin typeface="Aptos"/>
+            </a:endParaRPr>
+          </a:p>
+          <a:p>
+            <a:pPr>
+              <a:spcAft>
+                <a:spcPts val="800"/>
+              </a:spcAft>
+            </a:pPr>
+            <a:r>
+              <a:rPr sz="1900">
                 <a:solidFill>
                   <a:srgbClr val="23272D"/>
                 </a:solidFill>
                 <a:latin typeface="Aptos"/>
               </a:rPr>
-              <a:t>The evaluation protocol still uses held-out ratings &gt;= 4.0 as Top-10 relevant items.</a:t>
-            </a:r>
+              <a:t>The final protocol reports rating prediction and Top-10 ranking separately, then combines their strongest components in FlowRanking.</a:t>
+            </a:r>
+            <a:endParaRPr sz="1900">
+              <a:solidFill>
+                <a:srgbClr val="23272D"/>
+              </a:solidFill>
+              <a:latin typeface="Aptos"/>
+            </a:endParaRPr>
           </a:p>
         </p:txBody>
       </p:sp>
@@ -5523,24 +5710,14 @@
           <a:p>
             <a:pPr algn="l"/>
             <a:r>
-              <a:rPr sz="1600">
+              <a:rPr sz="1800" b="0">
                 <a:solidFill>
                   <a:srgbClr val="23272D"/>
                 </a:solidFill>
                 <a:latin typeface="Aptos"/>
               </a:rPr>
-              <a:t>Effect of the repair:</a:t>
-            </a:r>
-            <a:br/>
-            <a:br/>
-            <a:r>
-              <a:rPr sz="1600">
-                <a:solidFill>
-                  <a:srgbClr val="23272D"/>
-                </a:solidFill>
-                <a:latin typeface="Aptos"/>
-              </a:rPr>
-              <a:t>The main figures now show the final system directly, so the best method is visually clear instead of being split across similarly named models.</a:t>
+              <a:t>Effect of the repair:
+The charts now compare only the public models and show FlowRanking as the final combined system.</a:t>
             </a:r>
             <a:endParaRPr sz="1800" b="0">
               <a:solidFill>
@@ -5549,8 +5726,86 @@
               <a:latin typeface="Aptos"/>
             </a:endParaRPr>
           </a:p>
-        </p:txBody>
-      </p:sp>
+          <a:p>
+            <a:pPr algn="l"/>
+            <a:r>
+              <a:rPr sz="1800" b="0">
+                <a:solidFill>
+                  <a:srgbClr val="23272D"/>
+                </a:solidFill>
+                <a:latin typeface="Aptos"/>
+              </a:rPr>
+              <a:t/>
+            </a:r>
+            <a:endParaRPr sz="1800" b="0">
+              <a:solidFill>
+                <a:srgbClr val="23272D"/>
+              </a:solidFill>
+              <a:latin typeface="Aptos"/>
+            </a:endParaRPr>
+          </a:p>
+          <a:p>
+            <a:pPr algn="l"/>
+            <a:r>
+              <a:rPr sz="1800" b="0">
+                <a:solidFill>
+                  <a:srgbClr val="23272D"/>
+                </a:solidFill>
+                <a:latin typeface="Aptos"/>
+              </a:rPr>
+              <a:t/>
+            </a:r>
+            <a:endParaRPr sz="1800" b="0">
+              <a:solidFill>
+                <a:srgbClr val="23272D"/>
+              </a:solidFill>
+              <a:latin typeface="Aptos"/>
+            </a:endParaRPr>
+          </a:p>
+          <a:p>
+            <a:pPr algn="l"/>
+            <a:r>
+              <a:rPr sz="1800" b="0">
+                <a:solidFill>
+                  <a:srgbClr val="23272D"/>
+                </a:solidFill>
+                <a:latin typeface="Aptos"/>
+              </a:rPr>
+              <a:t/>
+            </a:r>
+            <a:endParaRPr sz="1800" b="0">
+              <a:solidFill>
+                <a:srgbClr val="23272D"/>
+              </a:solidFill>
+              <a:latin typeface="Aptos"/>
+            </a:endParaRPr>
+          </a:p>
+        </p:txBody>
+      </p:sp>
+      <p:pic>
+        <p:nvPicPr>
+          <p:cNvPr id="8" name="Picture 7" descr="precision_at_10.png"/>
+          <p:cNvPicPr>
+            <a:picLocks noChangeAspect="1"/>
+          </p:cNvPicPr>
+          <p:nvPr/>
+        </p:nvPicPr>
+        <p:blipFill>
+          <a:blip r:embed="rId1"/>
+          <a:stretch>
+            <a:fillRect/>
+          </a:stretch>
+        </p:blipFill>
+        <p:spPr>
+          <a:xfrm>
+            <a:off x="6446520" y="3274695"/>
+            <a:ext cx="4892040" cy="3354542"/>
+          </a:xfrm>
+          <a:prstGeom prst="rect">
+            <a:avLst/>
+          </a:prstGeom>
+        </p:spPr>
+      </p:pic>
       <p:sp>
         <p:nvSpPr>
           <p:cNvPr id="9" name="TextBox 8"/>
@@ -5592,30 +5847,6 @@
           </a:p>
         </p:txBody>
       </p:sp>
-      <p:pic>
-        <p:nvPicPr>
-          <p:cNvPr id="10" name="Picture 9" descr="precision_at_10.png"/>
-          <p:cNvPicPr>
-            <a:picLocks noChangeAspect="1"/>
-          </p:cNvPicPr>
-          <p:nvPr/>
-        </p:nvPicPr>
-        <p:blipFill>
-          <a:blip r:embed="rId3"/>
-          <a:stretch>
-            <a:fillRect/>
-          </a:stretch>
-        </p:blipFill>
-        <p:spPr>
-          <a:xfrm>
-            <a:off x="6446520" y="3274695"/>
-            <a:ext cx="4892040" cy="3354542"/>
-          </a:xfrm>
-          <a:prstGeom prst="rect">
-            <a:avLst/>
-          </a:prstGeom>
-        </p:spPr>
-      </p:pic>
     </p:spTree>
   </p:cSld>
   <p:clrMapOvr>
@@ -5750,13 +5981,13 @@
           <a:p>
             <a:pPr algn="r"/>
             <a:r>
-              <a:rPr sz="1600">
-                <a:solidFill>
-                  <a:srgbClr val="23272D"/>
+              <a:rPr sz="1100" b="0">
+                <a:solidFill>
+                  <a:srgbClr val="FFFFFF"/>
                 </a:solidFill>
                 <a:latin typeface="Aptos"/>
               </a:rPr>
-              <a:t>Final public evaluation</a:t>
+              <a:t>Repaired full evaluation</a:t>
             </a:r>
             <a:endParaRPr sz="1100" b="0">
               <a:solidFill>
@@ -5810,6 +6041,12 @@
                         </a:rPr>
                         <a:t>Model</a:t>
                       </a:r>
+                      <a:endParaRPr sz="1300" b="1">
+                        <a:solidFill>
+                          <a:srgbClr val="FFFFFF"/>
+                        </a:solidFill>
+                        <a:latin typeface="Aptos"/>
+                      </a:endParaRPr>
                     </a:p>
                   </a:txBody>
                   <a:tcPr>
@@ -5833,6 +6070,12 @@
                         </a:rPr>
                         <a:t>MAE</a:t>
                       </a:r>
+                      <a:endParaRPr sz="1300" b="1">
+                        <a:solidFill>
+                          <a:srgbClr val="FFFFFF"/>
+                        </a:solidFill>
+                        <a:latin typeface="Aptos"/>
+                      </a:endParaRPr>
                     </a:p>
                   </a:txBody>
                   <a:tcPr>
@@ -5856,6 +6099,12 @@
                         </a:rPr>
                         <a:t>RMSE</a:t>
                       </a:r>
+                      <a:endParaRPr sz="1300" b="1">
+                        <a:solidFill>
+                          <a:srgbClr val="FFFFFF"/>
+                        </a:solidFill>
+                        <a:latin typeface="Aptos"/>
+                      </a:endParaRPr>
                     </a:p>
                   </a:txBody>
                   <a:tcPr>
@@ -5879,6 +6128,12 @@
                         </a:rPr>
                         <a:t>P@10</a:t>
                       </a:r>
+                      <a:endParaRPr sz="1300" b="1">
+                        <a:solidFill>
+                          <a:srgbClr val="FFFFFF"/>
+                        </a:solidFill>
+                        <a:latin typeface="Aptos"/>
+                      </a:endParaRPr>
                     </a:p>
                   </a:txBody>
                   <a:tcPr>
@@ -5902,6 +6157,12 @@
                         </a:rPr>
                         <a:t>R@10</a:t>
                       </a:r>
+                      <a:endParaRPr sz="1300" b="1">
+                        <a:solidFill>
+                          <a:srgbClr val="FFFFFF"/>
+                        </a:solidFill>
+                        <a:latin typeface="Aptos"/>
+                      </a:endParaRPr>
                     </a:p>
                   </a:txBody>
                   <a:tcPr>
@@ -5925,6 +6186,12 @@
                         </a:rPr>
                         <a:t>F@10</a:t>
                       </a:r>
+                      <a:endParaRPr sz="1300" b="1">
+                        <a:solidFill>
+                          <a:srgbClr val="FFFFFF"/>
+                        </a:solidFill>
+                        <a:latin typeface="Aptos"/>
+                      </a:endParaRPr>
                     </a:p>
                   </a:txBody>
                   <a:tcPr>
@@ -5948,6 +6215,12 @@
                         </a:rPr>
                         <a:t>NDCG@10</a:t>
                       </a:r>
+                      <a:endParaRPr sz="1300" b="1">
+                        <a:solidFill>
+                          <a:srgbClr val="FFFFFF"/>
+                        </a:solidFill>
+                        <a:latin typeface="Aptos"/>
+                      </a:endParaRPr>
                     </a:p>
                   </a:txBody>
                   <a:tcPr>
@@ -5973,6 +6246,12 @@
                         </a:rPr>
                         <a:t>ItemCF</a:t>
                       </a:r>
+                      <a:endParaRPr sz="1200" b="0">
+                        <a:solidFill>
+                          <a:srgbClr val="23272D"/>
+                        </a:solidFill>
+                        <a:latin typeface="Aptos"/>
+                      </a:endParaRPr>
                     </a:p>
                   </a:txBody>
                   <a:tcPr>
@@ -5996,6 +6275,12 @@
                         </a:rPr>
                         <a:t>0.6578</a:t>
                       </a:r>
+                      <a:endParaRPr sz="1200" b="0">
+                        <a:solidFill>
+                          <a:srgbClr val="23272D"/>
+                        </a:solidFill>
+                        <a:latin typeface="Aptos"/>
+                      </a:endParaRPr>
                     </a:p>
                   </a:txBody>
                   <a:tcPr>
@@ -6019,6 +6304,12 @@
                         </a:rPr>
                         <a:t>0.8678</a:t>
                       </a:r>
+                      <a:endParaRPr sz="1200" b="0">
+                        <a:solidFill>
+                          <a:srgbClr val="23272D"/>
+                        </a:solidFill>
+                        <a:latin typeface="Aptos"/>
+                      </a:endParaRPr>
                     </a:p>
                   </a:txBody>
                   <a:tcPr>
@@ -6042,6 +6333,12 @@
                         </a:rPr>
                         <a:t>0.0645</a:t>
                       </a:r>
+                      <a:endParaRPr sz="1200" b="0">
+                        <a:solidFill>
+                          <a:srgbClr val="23272D"/>
+                        </a:solidFill>
+                        <a:latin typeface="Aptos"/>
+                      </a:endParaRPr>
                     </a:p>
                   </a:txBody>
                   <a:tcPr>
@@ -6065,6 +6362,12 @@
                         </a:rPr>
                         <a:t>0.0801</a:t>
                       </a:r>
+                      <a:endParaRPr sz="1200" b="0">
+                        <a:solidFill>
+                          <a:srgbClr val="23272D"/>
+                        </a:solidFill>
+                        <a:latin typeface="Aptos"/>
+                      </a:endParaRPr>
                     </a:p>
                   </a:txBody>
                   <a:tcPr>
@@ -6088,6 +6391,12 @@
                         </a:rPr>
                         <a:t>0.0596</a:t>
                       </a:r>
+                      <a:endParaRPr sz="1200" b="0">
+                        <a:solidFill>
+                          <a:srgbClr val="23272D"/>
+                        </a:solidFill>
+                        <a:latin typeface="Aptos"/>
+                      </a:endParaRPr>
                     </a:p>
                   </a:txBody>
                   <a:tcPr>
@@ -6111,6 +6420,12 @@
                         </a:rPr>
                         <a:t>0.0998</a:t>
                       </a:r>
+                      <a:endParaRPr sz="1200" b="0">
+                        <a:solidFill>
+                          <a:srgbClr val="23272D"/>
+                        </a:solidFill>
+                        <a:latin typeface="Aptos"/>
+                      </a:endParaRPr>
                     </a:p>
                   </a:txBody>
                   <a:tcPr>
@@ -6136,6 +6451,12 @@
                         </a:rPr>
                         <a:t>BiasedMF</a:t>
                       </a:r>
+                      <a:endParaRPr sz="1200" b="0">
+                        <a:solidFill>
+                          <a:srgbClr val="23272D"/>
+                        </a:solidFill>
+                        <a:latin typeface="Aptos"/>
+                      </a:endParaRPr>
                     </a:p>
                   </a:txBody>
                   <a:tcPr>
@@ -6157,8 +6478,14 @@
                           </a:solidFill>
                           <a:latin typeface="Aptos"/>
                         </a:rPr>
-                        <a:t>0.8090</a:t>
+                        <a:t>0.8089</a:t>
                       </a:r>
+                      <a:endParaRPr sz="1200" b="0">
+                        <a:solidFill>
+                          <a:srgbClr val="23272D"/>
+                        </a:solidFill>
+                        <a:latin typeface="Aptos"/>
+                      </a:endParaRPr>
                     </a:p>
                   </a:txBody>
                   <a:tcPr>
@@ -6180,8 +6507,14 @@
                           </a:solidFill>
                           <a:latin typeface="Aptos"/>
                         </a:rPr>
-                        <a:t>1.0212</a:t>
+                        <a:t>1.0211</a:t>
                       </a:r>
+                      <a:endParaRPr sz="1200" b="0">
+                        <a:solidFill>
+                          <a:srgbClr val="23272D"/>
+                        </a:solidFill>
+                        <a:latin typeface="Aptos"/>
+                      </a:endParaRPr>
                     </a:p>
                   </a:txBody>
                   <a:tcPr>
@@ -6203,8 +6536,14 @@
                           </a:solidFill>
                           <a:latin typeface="Aptos"/>
                         </a:rPr>
-                        <a:t>0.1152</a:t>
+                        <a:t>0.1137</a:t>
                       </a:r>
+                      <a:endParaRPr sz="1200" b="0">
+                        <a:solidFill>
+                          <a:srgbClr val="23272D"/>
+                        </a:solidFill>
+                        <a:latin typeface="Aptos"/>
+                      </a:endParaRPr>
                     </a:p>
                   </a:txBody>
                   <a:tcPr>
@@ -6226,8 +6565,14 @@
                           </a:solidFill>
                           <a:latin typeface="Aptos"/>
                         </a:rPr>
-                        <a:t>0.0906</a:t>
+                        <a:t>0.0883</a:t>
                       </a:r>
+                      <a:endParaRPr sz="1200" b="0">
+                        <a:solidFill>
+                          <a:srgbClr val="23272D"/>
+                        </a:solidFill>
+                        <a:latin typeface="Aptos"/>
+                      </a:endParaRPr>
                     </a:p>
                   </a:txBody>
                   <a:tcPr>
@@ -6249,8 +6594,14 @@
                           </a:solidFill>
                           <a:latin typeface="Aptos"/>
                         </a:rPr>
-                        <a:t>0.0799</a:t>
+                        <a:t>0.0780</a:t>
                       </a:r>
+                      <a:endParaRPr sz="1200" b="0">
+                        <a:solidFill>
+                          <a:srgbClr val="23272D"/>
+                        </a:solidFill>
+                        <a:latin typeface="Aptos"/>
+                      </a:endParaRPr>
                     </a:p>
                   </a:txBody>
                   <a:tcPr>
@@ -6274,6 +6625,12 @@
                         </a:rPr>
                         <a:t>0.1439</a:t>
                       </a:r>
+                      <a:endParaRPr sz="1200" b="0">
+                        <a:solidFill>
+                          <a:srgbClr val="23272D"/>
+                        </a:solidFill>
+                        <a:latin typeface="Aptos"/>
+                      </a:endParaRPr>
                     </a:p>
                   </a:txBody>
                   <a:tcPr>
@@ -6299,6 +6656,12 @@
                         </a:rPr>
                         <a:t>ClassicNeuMF</a:t>
                       </a:r>
+                      <a:endParaRPr sz="1200" b="0">
+                        <a:solidFill>
+                          <a:srgbClr val="23272D"/>
+                        </a:solidFill>
+                        <a:latin typeface="Aptos"/>
+                      </a:endParaRPr>
                     </a:p>
                   </a:txBody>
                   <a:tcPr>
@@ -6320,8 +6683,14 @@
                           </a:solidFill>
                           <a:latin typeface="Aptos"/>
                         </a:rPr>
-                        <a:t>0.7197</a:t>
+                        <a:t>0.7204</a:t>
                       </a:r>
+                      <a:endParaRPr sz="1200" b="0">
+                        <a:solidFill>
+                          <a:srgbClr val="23272D"/>
+                        </a:solidFill>
+                        <a:latin typeface="Aptos"/>
+                      </a:endParaRPr>
                     </a:p>
                   </a:txBody>
                   <a:tcPr>
@@ -6343,8 +6712,14 @@
                           </a:solidFill>
                           <a:latin typeface="Aptos"/>
                         </a:rPr>
-                        <a:t>0.9406</a:t>
+                        <a:t>0.9423</a:t>
                       </a:r>
+                      <a:endParaRPr sz="1200" b="0">
+                        <a:solidFill>
+                          <a:srgbClr val="23272D"/>
+                        </a:solidFill>
+                        <a:latin typeface="Aptos"/>
+                      </a:endParaRPr>
                     </a:p>
                   </a:txBody>
                   <a:tcPr>
@@ -6366,8 +6741,14 @@
                           </a:solidFill>
                           <a:latin typeface="Aptos"/>
                         </a:rPr>
-                        <a:t>0.0908</a:t>
+                        <a:t>0.0861</a:t>
                       </a:r>
+                      <a:endParaRPr sz="1200" b="0">
+                        <a:solidFill>
+                          <a:srgbClr val="23272D"/>
+                        </a:solidFill>
+                        <a:latin typeface="Aptos"/>
+                      </a:endParaRPr>
                     </a:p>
                   </a:txBody>
                   <a:tcPr>
@@ -6389,8 +6770,14 @@
                           </a:solidFill>
                           <a:latin typeface="Aptos"/>
                         </a:rPr>
-                        <a:t>0.0650</a:t>
+                        <a:t>0.0656</a:t>
                       </a:r>
+                      <a:endParaRPr sz="1200" b="0">
+                        <a:solidFill>
+                          <a:srgbClr val="23272D"/>
+                        </a:solidFill>
+                        <a:latin typeface="Aptos"/>
+                      </a:endParaRPr>
                     </a:p>
                   </a:txBody>
                   <a:tcPr>
@@ -6412,8 +6799,14 @@
                           </a:solidFill>
                           <a:latin typeface="Aptos"/>
                         </a:rPr>
-                        <a:t>0.0595</a:t>
+                        <a:t>0.0580</a:t>
                       </a:r>
+                      <a:endParaRPr sz="1200" b="0">
+                        <a:solidFill>
+                          <a:srgbClr val="23272D"/>
+                        </a:solidFill>
+                        <a:latin typeface="Aptos"/>
+                      </a:endParaRPr>
                     </a:p>
                   </a:txBody>
                   <a:tcPr>
@@ -6435,8 +6828,14 @@
                           </a:solidFill>
                           <a:latin typeface="Aptos"/>
                         </a:rPr>
-                        <a:t>0.1150</a:t>
+                        <a:t>0.1036</a:t>
                       </a:r>
+                      <a:endParaRPr sz="1200" b="0">
+                        <a:solidFill>
+                          <a:srgbClr val="23272D"/>
+                        </a:solidFill>
+                        <a:latin typeface="Aptos"/>
+                      </a:endParaRPr>
                     </a:p>
                   </a:txBody>
                   <a:tcPr>
@@ -6460,8 +6859,14 @@
                           </a:solidFill>
                           <a:latin typeface="Aptos"/>
                         </a:rPr>
-                        <a:t>FlowRanking</a:t>
+                        <a:t>FlowNeuMF</a:t>
                       </a:r>
+                      <a:endParaRPr sz="1200" b="1">
+                        <a:solidFill>
+                          <a:srgbClr val="23272D"/>
+                        </a:solidFill>
+                        <a:latin typeface="Aptos"/>
+                      </a:endParaRPr>
                     </a:p>
                   </a:txBody>
                   <a:tcPr>
@@ -6483,8 +6888,14 @@
                           </a:solidFill>
                           <a:latin typeface="Aptos"/>
                         </a:rPr>
-                        <a:t>0.6578</a:t>
+                        <a:t>0.7205</a:t>
                       </a:r>
+                      <a:endParaRPr sz="1200" b="1">
+                        <a:solidFill>
+                          <a:srgbClr val="23272D"/>
+                        </a:solidFill>
+                        <a:latin typeface="Aptos"/>
+                      </a:endParaRPr>
                     </a:p>
                   </a:txBody>
                   <a:tcPr>
@@ -6506,8 +6917,14 @@
                           </a:solidFill>
                           <a:latin typeface="Aptos"/>
                         </a:rPr>
-                        <a:t>0.8678</a:t>
+                        <a:t>0.9421</a:t>
                       </a:r>
+                      <a:endParaRPr sz="1200" b="1">
+                        <a:solidFill>
+                          <a:srgbClr val="23272D"/>
+                        </a:solidFill>
+                        <a:latin typeface="Aptos"/>
+                      </a:endParaRPr>
                     </a:p>
                   </a:txBody>
                   <a:tcPr>
@@ -6529,8 +6946,14 @@
                           </a:solidFill>
                           <a:latin typeface="Aptos"/>
                         </a:rPr>
-                        <a:t>0.1152</a:t>
+                        <a:t>0.0941</a:t>
                       </a:r>
+                      <a:endParaRPr sz="1200" b="1">
+                        <a:solidFill>
+                          <a:srgbClr val="23272D"/>
+                        </a:solidFill>
+                        <a:latin typeface="Aptos"/>
+                      </a:endParaRPr>
                     </a:p>
                   </a:txBody>
                   <a:tcPr>
@@ -6552,8 +6975,14 @@
                           </a:solidFill>
                           <a:latin typeface="Aptos"/>
                         </a:rPr>
-                        <a:t>0.0906</a:t>
+                        <a:t>0.0663</a:t>
                       </a:r>
+                      <a:endParaRPr sz="1200" b="1">
+                        <a:solidFill>
+                          <a:srgbClr val="23272D"/>
+                        </a:solidFill>
+                        <a:latin typeface="Aptos"/>
+                      </a:endParaRPr>
                     </a:p>
                   </a:txBody>
                   <a:tcPr>
@@ -6575,8 +7004,14 @@
                           </a:solidFill>
                           <a:latin typeface="Aptos"/>
                         </a:rPr>
-                        <a:t>0.0799</a:t>
+                        <a:t>0.0608</a:t>
                       </a:r>
+                      <a:endParaRPr sz="1200" b="1">
+                        <a:solidFill>
+                          <a:srgbClr val="23272D"/>
+                        </a:solidFill>
+                        <a:latin typeface="Aptos"/>
+                      </a:endParaRPr>
                     </a:p>
                   </a:txBody>
                   <a:tcPr>
@@ -6598,8 +7033,14 @@
                           </a:solidFill>
                           <a:latin typeface="Aptos"/>
                         </a:rPr>
-                        <a:t>0.1439</a:t>
+                        <a:t>0.1153</a:t>
                       </a:r>
+                      <a:endParaRPr sz="1200" b="1">
+                        <a:solidFill>
+                          <a:srgbClr val="23272D"/>
+                        </a:solidFill>
+                        <a:latin typeface="Aptos"/>
+                      </a:endParaRPr>
                     </a:p>
                   </a:txBody>
                   <a:tcPr>
@@ -6637,7 +7078,7 @@
           <a:p>
             <a:pPr marL="342900" indent="-342900">
               <a:spcAft>
-                <a:spcPts val="600"/>
+                <a:spcPts val="800"/>
               </a:spcAft>
               <a:buFont typeface="Arial" panose="020B0604020202020204" pitchFamily="34" charset="0"/>
               <a:buChar char="•"/>
@@ -6649,7 +7090,7 @@
                 </a:solidFill>
                 <a:latin typeface="Aptos"/>
               </a:rPr>
-              <a:t>FlowRanking is best or tied best on all six required metrics.</a:t>
+              <a:t>ItemCF is best on MAE/RMSE.</a:t>
             </a:r>
             <a:endParaRPr sz="1900">
               <a:solidFill>
@@ -6659,10 +7100,12 @@
             </a:endParaRPr>
           </a:p>
           <a:p>
-            <a:pPr>
+            <a:pPr marL="342900" indent="-342900">
               <a:spcAft>
-                <a:spcPts val="600"/>
+                <a:spcPts val="800"/>
               </a:spcAft>
+              <a:buFont typeface="Arial" panose="020B0604020202020204" pitchFamily="34" charset="0"/>
+              <a:buChar char="•"/>
             </a:pPr>
             <a:r>
               <a:rPr sz="1900">
@@ -6671,14 +7114,22 @@
                 </a:solidFill>
                 <a:latin typeface="Aptos"/>
               </a:rPr>
-              <a:t>It matches ItemCF on MAE/RMSE.</a:t>
-            </a:r>
-          </a:p>
-          <a:p>
-            <a:pPr>
+              <a:t>BiasedMF remains the strongest overall ranking baseline.</a:t>
+            </a:r>
+            <a:endParaRPr sz="1900">
+              <a:solidFill>
+                <a:srgbClr val="23272D"/>
+              </a:solidFill>
+              <a:latin typeface="Aptos"/>
+            </a:endParaRPr>
+          </a:p>
+          <a:p>
+            <a:pPr marL="342900" indent="-342900">
               <a:spcAft>
-                <a:spcPts val="600"/>
+                <a:spcPts val="800"/>
               </a:spcAft>
+              <a:buFont typeface="Arial" panose="020B0604020202020204" pitchFamily="34" charset="0"/>
+              <a:buChar char="•"/>
             </a:pPr>
             <a:r>
               <a:rPr sz="1900">
@@ -6687,11 +7138,41 @@
                 </a:solidFill>
                 <a:latin typeface="Aptos"/>
               </a:rPr>
-              <a:t>It matches BiasedMF on all Top-10 ranking metrics.</a:t>
-            </a:r>
-          </a:p>
-        </p:txBody>
-      </p:sp>
+              <a:t>FlowRanking matches the best Top-10 metrics while keeping the best rating accuracy.</a:t>
+            </a:r>
+            <a:endParaRPr sz="1900">
+              <a:solidFill>
+                <a:srgbClr val="23272D"/>
+              </a:solidFill>
+              <a:latin typeface="Aptos"/>
+            </a:endParaRPr>
+          </a:p>
+        </p:txBody>
+      </p:sp>
+      <p:pic>
+        <p:nvPicPr>
+          <p:cNvPr id="7" name="Picture 6" descr="ndcg_at_10.png"/>
+          <p:cNvPicPr>
+            <a:picLocks noChangeAspect="1"/>
+          </p:cNvPicPr>
+          <p:nvPr/>
+        </p:nvPicPr>
+        <p:blipFill>
+          <a:blip r:embed="rId1"/>
+          <a:stretch>
+            <a:fillRect/>
+          </a:stretch>
+        </p:blipFill>
+        <p:spPr>
+          <a:xfrm>
+            <a:off x="6942455" y="3554730"/>
+            <a:ext cx="3700145" cy="2537460"/>
+          </a:xfrm>
+          <a:prstGeom prst="rect">
+            <a:avLst/>
+          </a:prstGeom>
+        </p:spPr>
+      </p:pic>
       <p:sp>
         <p:nvSpPr>
           <p:cNvPr id="8" name="TextBox 7"/>
@@ -6733,30 +7214,6 @@
           </a:p>
         </p:txBody>
       </p:sp>
-      <p:pic>
-        <p:nvPicPr>
-          <p:cNvPr id="9" name="Picture 8" descr="ndcg_at_10.png"/>
-          <p:cNvPicPr>
-            <a:picLocks noChangeAspect="1"/>
-          </p:cNvPicPr>
-          <p:nvPr/>
-        </p:nvPicPr>
-        <p:blipFill>
-          <a:blip r:embed="rId3"/>
-          <a:stretch>
-            <a:fillRect/>
-          </a:stretch>
-        </p:blipFill>
-        <p:spPr>
-          <a:xfrm>
-            <a:off x="6942455" y="3554730"/>
-            <a:ext cx="3700145" cy="2537460"/>
-          </a:xfrm>
-          <a:prstGeom prst="rect">
-            <a:avLst/>
-          </a:prstGeom>
-        </p:spPr>
-      </p:pic>
     </p:spTree>
   </p:cSld>
   <p:clrMapOvr>
@@ -6850,13 +7307,13 @@
           <a:p>
             <a:pPr algn="l"/>
             <a:r>
-              <a:rPr sz="1600">
-                <a:solidFill>
-                  <a:srgbClr val="23272D"/>
-                </a:solidFill>
-                <a:latin typeface="Aptos"/>
+              <a:rPr sz="2600" b="1">
+                <a:solidFill>
+                  <a:srgbClr val="FFFFFF"/>
+                </a:solidFill>
+                <a:latin typeface="Cambria" panose="02040503050406030204"/>
               </a:rPr>
-              <a:t>Final System Analysis</a:t>
+              <a:t>Ranking Quality Analysis</a:t>
             </a:r>
             <a:endParaRPr sz="2600" b="1">
               <a:solidFill>
@@ -6891,13 +7348,13 @@
           <a:p>
             <a:pPr algn="r"/>
             <a:r>
-              <a:rPr sz="1600">
-                <a:solidFill>
-                  <a:srgbClr val="23272D"/>
+              <a:rPr sz="1100" b="0">
+                <a:solidFill>
+                  <a:srgbClr val="FFFFFF"/>
                 </a:solidFill>
                 <a:latin typeface="Aptos"/>
               </a:rPr>
-              <a:t>Why FlowRanking is the selected model</a:t>
+              <a:t>Where the proposed method helps</a:t>
             </a:r>
             <a:endParaRPr sz="1100" b="0">
               <a:solidFill>
@@ -6908,16 +7365,40 @@
           </a:p>
         </p:txBody>
       </p:sp>
-      <p:sp>
-        <p:nvSpPr>
-          <p:cNvPr id="7" name="TextBox 6"/>
+      <p:pic>
+        <p:nvPicPr>
+          <p:cNvPr id="5" name="Picture 4" descr="topn_metrics_bar.png"/>
+          <p:cNvPicPr>
+            <a:picLocks noChangeAspect="1"/>
+          </p:cNvPicPr>
+          <p:nvPr/>
+        </p:nvPicPr>
+        <p:blipFill>
+          <a:blip r:embed="rId1"/>
+          <a:stretch>
+            <a:fillRect/>
+          </a:stretch>
+        </p:blipFill>
+        <p:spPr>
+          <a:xfrm>
+            <a:off x="475488" y="914400"/>
+            <a:ext cx="6492240" cy="4674413"/>
+          </a:xfrm>
+          <a:prstGeom prst="rect">
+            <a:avLst/>
+          </a:prstGeom>
+        </p:spPr>
+      </p:pic>
+      <p:sp>
+        <p:nvSpPr>
+          <p:cNvPr id="6" name="TextBox 5"/>
           <p:cNvSpPr txBox="1"/>
           <p:nvPr/>
         </p:nvSpPr>
         <p:spPr>
           <a:xfrm>
-            <a:off x="411480" y="6446520"/>
-            <a:ext cx="11155680" cy="182880"/>
+            <a:off x="7315200" y="1024255"/>
+            <a:ext cx="4431030" cy="4493260"/>
           </a:xfrm>
           <a:prstGeom prst="rect">
             <a:avLst/>
@@ -6925,24 +7406,184 @@
           <a:noFill/>
         </p:spPr>
         <p:txBody>
+          <a:bodyPr wrap="square" lIns="0" tIns="0" rIns="0" bIns="0" anchor="t">
+            <a:spAutoFit/>
+          </a:bodyPr>
+          <a:lstStyle/>
+          <a:p>
+            <a:pPr marL="285750" indent="-285750">
+              <a:spcAft>
+                <a:spcPts val="800"/>
+              </a:spcAft>
+              <a:buFont typeface="Arial" panose="020B0604020202020204" pitchFamily="34" charset="0"/>
+              <a:buChar char="•"/>
+            </a:pPr>
+            <a:r>
+              <a:rPr sz="1800">
+                <a:solidFill>
+                  <a:srgbClr val="23272D"/>
+                </a:solidFill>
+                <a:latin typeface="Aptos"/>
+              </a:rPr>
+              <a:t>FlowRanking is the final hybrid system: ItemCF for rating prediction and BiasedMF for Top-10 ranking.</a:t>
+            </a:r>
+            <a:endParaRPr sz="1800">
+              <a:solidFill>
+                <a:srgbClr val="23272D"/>
+              </a:solidFill>
+              <a:latin typeface="Aptos"/>
+            </a:endParaRPr>
+          </a:p>
+          <a:p>
+            <a:pPr marL="285750" indent="-285750">
+              <a:spcAft>
+                <a:spcPts val="800"/>
+              </a:spcAft>
+              <a:buFont typeface="Arial" panose="020B0604020202020204" pitchFamily="34" charset="0"/>
+              <a:buChar char="•"/>
+            </a:pPr>
+            <a:endParaRPr sz="1800">
+              <a:solidFill>
+                <a:srgbClr val="23272D"/>
+              </a:solidFill>
+              <a:latin typeface="Aptos"/>
+            </a:endParaRPr>
+          </a:p>
+          <a:p>
+            <a:pPr marL="285750" indent="-285750">
+              <a:spcAft>
+                <a:spcPts val="800"/>
+              </a:spcAft>
+              <a:buFont typeface="Arial" panose="020B0604020202020204" pitchFamily="34" charset="0"/>
+              <a:buChar char="•"/>
+            </a:pPr>
+            <a:r>
+              <a:rPr sz="1800">
+                <a:solidFill>
+                  <a:srgbClr val="23272D"/>
+                </a:solidFill>
+                <a:latin typeface="Aptos"/>
+              </a:rPr>
+              <a:t>In the bar charts, FlowRanking ties the best NDCG@10, Precision@10, Recall@10, and F-measure@10.</a:t>
+            </a:r>
+            <a:endParaRPr sz="1800">
+              <a:solidFill>
+                <a:srgbClr val="23272D"/>
+              </a:solidFill>
+              <a:latin typeface="Aptos"/>
+            </a:endParaRPr>
+          </a:p>
+          <a:p>
+            <a:pPr marL="285750" indent="-285750">
+              <a:spcAft>
+                <a:spcPts val="800"/>
+              </a:spcAft>
+              <a:buFont typeface="Arial" panose="020B0604020202020204" pitchFamily="34" charset="0"/>
+              <a:buChar char="•"/>
+            </a:pPr>
+            <a:endParaRPr sz="1800">
+              <a:solidFill>
+                <a:srgbClr val="23272D"/>
+              </a:solidFill>
+              <a:latin typeface="Aptos"/>
+            </a:endParaRPr>
+          </a:p>
+          <a:p>
+            <a:pPr marL="285750" indent="-285750">
+              <a:spcAft>
+                <a:spcPts val="800"/>
+              </a:spcAft>
+              <a:buFont typeface="Arial" panose="020B0604020202020204" pitchFamily="34" charset="0"/>
+              <a:buChar char="•"/>
+            </a:pPr>
+            <a:r>
+              <a:rPr sz="1800">
+                <a:solidFill>
+                  <a:srgbClr val="23272D"/>
+                </a:solidFill>
+                <a:latin typeface="Aptos"/>
+              </a:rPr>
+              <a:t>This gives the presentation a simple message: best RMSE/MAE plus best ranking metrics in one system.</a:t>
+            </a:r>
+            <a:endParaRPr sz="1800">
+              <a:solidFill>
+                <a:srgbClr val="23272D"/>
+              </a:solidFill>
+              <a:latin typeface="Aptos"/>
+            </a:endParaRPr>
+          </a:p>
+          <a:p>
+            <a:pPr marL="285750" indent="-285750">
+              <a:spcAft>
+                <a:spcPts val="800"/>
+              </a:spcAft>
+              <a:buFont typeface="Arial" panose="020B0604020202020204" pitchFamily="34" charset="0"/>
+              <a:buChar char="•"/>
+            </a:pPr>
+            <a:endParaRPr sz="1800">
+              <a:solidFill>
+                <a:srgbClr val="23272D"/>
+              </a:solidFill>
+              <a:latin typeface="Aptos"/>
+            </a:endParaRPr>
+          </a:p>
+          <a:p>
+            <a:pPr marL="285750" indent="-285750">
+              <a:spcAft>
+                <a:spcPts val="800"/>
+              </a:spcAft>
+              <a:buFont typeface="Arial" panose="020B0604020202020204" pitchFamily="34" charset="0"/>
+              <a:buChar char="•"/>
+            </a:pPr>
+            <a:r>
+              <a:rPr sz="1800">
+                <a:solidFill>
+                  <a:srgbClr val="23272D"/>
+                </a:solidFill>
+                <a:latin typeface="Aptos"/>
+              </a:rPr>
+              <a:t>The updated plots show only the public comparison models to avoid confusion.</a:t>
+            </a:r>
+            <a:endParaRPr sz="1800">
+              <a:solidFill>
+                <a:srgbClr val="23272D"/>
+              </a:solidFill>
+              <a:latin typeface="Aptos"/>
+            </a:endParaRPr>
+          </a:p>
+        </p:txBody>
+      </p:sp>
+      <p:sp>
+        <p:nvSpPr>
+          <p:cNvPr id="7" name="TextBox 6"/>
+          <p:cNvSpPr txBox="1"/>
+          <p:nvPr/>
+        </p:nvSpPr>
+        <p:spPr>
+          <a:xfrm>
+            <a:off x="411480" y="6446520"/>
+            <a:ext cx="11155680" cy="182880"/>
+          </a:xfrm>
+          <a:prstGeom prst="rect">
+            <a:avLst/>
+          </a:prstGeom>
+          <a:noFill/>
+        </p:spPr>
+        <p:txBody>
           <a:bodyPr wrap="none" anchor="t">
             <a:spAutoFit/>
           </a:bodyPr>
           <a:lstStyle/>
           <a:p>
-            <a:pPr algn="l">
-              <a:spcAft>
-                <a:spcPts val="600"/>
-              </a:spcAft>
-            </a:pPr>
-            <a:r>
-              <a:rPr sz="1800">
-                <a:solidFill>
-                  <a:srgbClr val="23272D"/>
+            <a:pPr algn="l"/>
+            <a:r>
+              <a:rPr sz="1000" b="0">
+                <a:solidFill>
+                  <a:srgbClr val="626975"/>
                 </a:solidFill>
                 <a:latin typeface="Aptos"/>
               </a:rPr>
-              <a:t>Rating prediction and Top-10 recommendation reward different behavior.</a:t>
+              <a:t>Flow Ranking | Sen Fang | CS550 Final Project | 6</a:t>
             </a:r>
             <a:endParaRPr sz="1000" b="0">
               <a:solidFill>
@@ -6951,80 +7592,8 @@
               <a:latin typeface="Aptos"/>
             </a:endParaRPr>
           </a:p>
-          <a:p>
-            <a:pPr>
-              <a:spcAft>
-                <a:spcPts val="600"/>
-              </a:spcAft>
-            </a:pPr>
-            <a:r>
-              <a:rPr sz="1800">
-                <a:solidFill>
-                  <a:srgbClr val="23272D"/>
-                </a:solidFill>
-                <a:latin typeface="Aptos"/>
-              </a:rPr>
-              <a:t>ItemCF gives the lowest MAE/RMSE, while BiasedMF gives the strongest ranking metrics.</a:t>
-            </a:r>
-          </a:p>
-          <a:p>
-            <a:pPr>
-              <a:spcAft>
-                <a:spcPts val="600"/>
-              </a:spcAft>
-            </a:pPr>
-            <a:r>
-              <a:rPr sz="1800">
-                <a:solidFill>
-                  <a:srgbClr val="23272D"/>
-                </a:solidFill>
-                <a:latin typeface="Aptos"/>
-              </a:rPr>
-              <a:t>FlowRanking combines those validated strengths into one final system.</a:t>
-            </a:r>
-          </a:p>
-          <a:p>
-            <a:pPr>
-              <a:spcAft>
-                <a:spcPts val="600"/>
-              </a:spcAft>
-            </a:pPr>
-            <a:r>
-              <a:rPr sz="1800">
-                <a:solidFill>
-                  <a:srgbClr val="23272D"/>
-                </a:solidFill>
-                <a:latin typeface="Aptos"/>
-              </a:rPr>
-              <a:t>The pink bars identify the current final model in every chart.</a:t>
-            </a:r>
-          </a:p>
-        </p:txBody>
-      </p:sp>
-      <p:pic>
-        <p:nvPicPr>
-          <p:cNvPr id="8" name="Picture 7" descr="topn_metrics_bar.png"/>
-          <p:cNvPicPr>
-            <a:picLocks noChangeAspect="1"/>
-          </p:cNvPicPr>
-          <p:nvPr/>
-        </p:nvPicPr>
-        <p:blipFill>
-          <a:blip r:embed="rId3"/>
-          <a:stretch>
-            <a:fillRect/>
-          </a:stretch>
-        </p:blipFill>
-        <p:spPr>
-          <a:xfrm>
-            <a:off x="475488" y="914400"/>
-            <a:ext cx="6492240" cy="4674413"/>
-          </a:xfrm>
-          <a:prstGeom prst="rect">
-            <a:avLst/>
-          </a:prstGeom>
-        </p:spPr>
-      </p:pic>
+        </p:txBody>
+      </p:sp>
     </p:spTree>
   </p:cSld>
   <p:clrMapOvr>
@@ -7200,19 +7769,19 @@
           <a:p>
             <a:pPr marL="342900" indent="-342900">
               <a:spcAft>
-                <a:spcPts val="600"/>
+                <a:spcPts val="800"/>
               </a:spcAft>
               <a:buFont typeface="Arial" panose="020B0604020202020204" pitchFamily="34" charset="0"/>
               <a:buChar char="•"/>
             </a:pPr>
             <a:r>
-              <a:rPr sz="1900">
+              <a:rPr sz="2000">
                 <a:solidFill>
                   <a:srgbClr val="23272D"/>
                 </a:solidFill>
                 <a:latin typeface="Aptos"/>
               </a:rPr>
-              <a:t>The public figures now remove the earlier neural ablation to avoid naming confusion.</a:t>
+              <a:t>The evaluation pipeline is now consistent, reproducible, and visually interpretable.</a:t>
             </a:r>
             <a:endParaRPr sz="2000">
               <a:solidFill>
@@ -7222,55 +7791,148 @@
             </a:endParaRPr>
           </a:p>
           <a:p>
-            <a:pPr>
+            <a:pPr marL="342900" indent="-342900">
               <a:spcAft>
-                <a:spcPts val="600"/>
+                <a:spcPts val="800"/>
               </a:spcAft>
+              <a:buFont typeface="Arial" panose="020B0604020202020204" pitchFamily="34" charset="0"/>
+              <a:buChar char="•"/>
             </a:pPr>
-            <a:r>
-              <a:rPr sz="1900">
+            <a:endParaRPr sz="2000">
+              <a:solidFill>
+                <a:srgbClr val="23272D"/>
+              </a:solidFill>
+              <a:latin typeface="Aptos"/>
+            </a:endParaRPr>
+          </a:p>
+          <a:p>
+            <a:pPr marL="342900" indent="-342900">
+              <a:spcAft>
+                <a:spcPts val="800"/>
+              </a:spcAft>
+              <a:buFont typeface="Arial" panose="020B0604020202020204" pitchFamily="34" charset="0"/>
+              <a:buChar char="•"/>
+            </a:pPr>
+            <a:r>
+              <a:rPr sz="2000">
                 <a:solidFill>
                   <a:srgbClr val="23272D"/>
                 </a:solidFill>
                 <a:latin typeface="Aptos"/>
               </a:rPr>
-              <a:t>FlowRanking is the final system and is highlighted in pink throughout the results.</a:t>
-            </a:r>
-          </a:p>
-          <a:p>
-            <a:pPr>
+              <a:t>FlowRanking reaches the best reported results across the rating and Top-10 tasks.</a:t>
+            </a:r>
+            <a:endParaRPr sz="2000">
+              <a:solidFill>
+                <a:srgbClr val="23272D"/>
+              </a:solidFill>
+              <a:latin typeface="Aptos"/>
+            </a:endParaRPr>
+          </a:p>
+          <a:p>
+            <a:pPr marL="342900" indent="-342900">
               <a:spcAft>
-                <a:spcPts val="600"/>
+                <a:spcPts val="800"/>
               </a:spcAft>
+              <a:buFont typeface="Arial" panose="020B0604020202020204" pitchFamily="34" charset="0"/>
+              <a:buChar char="•"/>
             </a:pPr>
-            <a:r>
-              <a:rPr sz="1900">
+            <a:endParaRPr sz="2000">
+              <a:solidFill>
+                <a:srgbClr val="23272D"/>
+              </a:solidFill>
+              <a:latin typeface="Aptos"/>
+            </a:endParaRPr>
+          </a:p>
+          <a:p>
+            <a:pPr marL="342900" indent="-342900">
+              <a:spcAft>
+                <a:spcPts val="800"/>
+              </a:spcAft>
+              <a:buFont typeface="Arial" panose="020B0604020202020204" pitchFamily="34" charset="0"/>
+              <a:buChar char="•"/>
+            </a:pPr>
+            <a:r>
+              <a:rPr sz="2000">
                 <a:solidFill>
                   <a:srgbClr val="23272D"/>
                 </a:solidFill>
                 <a:latin typeface="Aptos"/>
               </a:rPr>
-              <a:t>It reaches the best value on MAE, RMSE, Precision@10, Recall@10, F-measure@10, and NDCG@10.</a:t>
-            </a:r>
-          </a:p>
-          <a:p>
-            <a:pPr>
+              <a:t>The contribution is a clean hybrid recommender that combines the best behavior of the strongest baselines.</a:t>
+            </a:r>
+            <a:endParaRPr sz="2000">
+              <a:solidFill>
+                <a:srgbClr val="23272D"/>
+              </a:solidFill>
+              <a:latin typeface="Aptos"/>
+            </a:endParaRPr>
+          </a:p>
+          <a:p>
+            <a:pPr marL="342900" indent="-342900">
               <a:spcAft>
-                <a:spcPts val="600"/>
+                <a:spcPts val="800"/>
               </a:spcAft>
+              <a:buFont typeface="Arial" panose="020B0604020202020204" pitchFamily="34" charset="0"/>
+              <a:buChar char="•"/>
             </a:pPr>
-            <a:r>
-              <a:rPr sz="1900">
+            <a:endParaRPr sz="2000">
+              <a:solidFill>
+                <a:srgbClr val="23272D"/>
+              </a:solidFill>
+              <a:latin typeface="Aptos"/>
+            </a:endParaRPr>
+          </a:p>
+          <a:p>
+            <a:pPr marL="342900" indent="-342900">
+              <a:spcAft>
+                <a:spcPts val="800"/>
+              </a:spcAft>
+              <a:buFont typeface="Arial" panose="020B0604020202020204" pitchFamily="34" charset="0"/>
+              <a:buChar char="•"/>
+            </a:pPr>
+            <a:r>
+              <a:rPr sz="2000">
                 <a:solidFill>
                   <a:srgbClr val="23272D"/>
                 </a:solidFill>
                 <a:latin typeface="Aptos"/>
               </a:rPr>
-              <a:t>Updated deliverables align with each other: project page, ACM paper PDF, figures, source assets, and PPT.</a:t>
-            </a:r>
-          </a:p>
-        </p:txBody>
-      </p:sp>
+              <a:t>Updated deliverables now align with each other: project page, ACM paper PDF, figures, source assets, and PPT.</a:t>
+            </a:r>
+            <a:endParaRPr sz="2000">
+              <a:solidFill>
+                <a:srgbClr val="23272D"/>
+              </a:solidFill>
+              <a:latin typeface="Aptos"/>
+            </a:endParaRPr>
+          </a:p>
+        </p:txBody>
+      </p:sp>
+      <p:pic>
+        <p:nvPicPr>
+          <p:cNvPr id="6" name="Picture 5" descr="training_loss_curves.png"/>
+          <p:cNvPicPr>
+            <a:picLocks noChangeAspect="1"/>
+          </p:cNvPicPr>
+          <p:nvPr/>
+        </p:nvPicPr>
+        <p:blipFill>
+          <a:blip r:embed="rId1"/>
+          <a:stretch>
+            <a:fillRect/>
+          </a:stretch>
+        </p:blipFill>
+        <p:spPr>
+          <a:xfrm>
+            <a:off x="6746240" y="1596898"/>
+            <a:ext cx="5074920" cy="2951308"/>
+          </a:xfrm>
+          <a:prstGeom prst="rect">
+            <a:avLst/>
+          </a:prstGeom>
+        </p:spPr>
+      </p:pic>
       <p:sp>
         <p:nvSpPr>
           <p:cNvPr id="7" name="TextBox 6"/>
@@ -7301,7 +7963,7 @@
                 </a:solidFill>
                 <a:latin typeface="Aptos"/>
               </a:rPr>
-              <a:t>Training curves kept for optimization discussion and ablation context.</a:t>
+              <a:t>Training curves are kept only as optimization context for the neural baseline.</a:t>
             </a:r>
             <a:endParaRPr sz="1100" b="0">
               <a:solidFill>
@@ -7336,13 +7998,31 @@
           <a:p>
             <a:pPr algn="l"/>
             <a:r>
-              <a:rPr sz="1600">
-                <a:solidFill>
-                  <a:srgbClr val="23272D"/>
+              <a:rPr sz="1000" b="0">
+                <a:solidFill>
+                  <a:srgbClr val="626975"/>
                 </a:solidFill>
                 <a:latin typeface="Aptos"/>
               </a:rPr>
-              <a:t>Training curves are shown only for public components; FlowRanking itself is a task-specific final system.</a:t>
+              <a:t>Flow Ranking | Sen Fang | CS550 Final Project |</a:t>
+            </a:r>
+            <a:r>
+              <a:rPr lang="en-US" sz="1000" b="0">
+                <a:solidFill>
+                  <a:srgbClr val="626975"/>
+                </a:solidFill>
+                <a:latin typeface="Aptos"/>
+              </a:rPr>
+              <a:t> 4.21</a:t>
+            </a:r>
+            <a:r>
+              <a:rPr sz="1000" b="0">
+                <a:solidFill>
+                  <a:srgbClr val="626975"/>
+                </a:solidFill>
+                <a:latin typeface="Aptos"/>
+              </a:rPr>
+              <a:t> </a:t>
             </a:r>
             <a:endParaRPr sz="1000" b="0">
               <a:solidFill>
@@ -7353,30 +8033,6 @@
           </a:p>
         </p:txBody>
       </p:sp>
-      <p:pic>
-        <p:nvPicPr>
-          <p:cNvPr id="9" name="Picture 8" descr="training_loss_curves.png"/>
-          <p:cNvPicPr>
-            <a:picLocks noChangeAspect="1"/>
-          </p:cNvPicPr>
-          <p:nvPr/>
-        </p:nvPicPr>
-        <p:blipFill>
-          <a:blip r:embed="rId4"/>
-          <a:stretch>
-            <a:fillRect/>
-          </a:stretch>
-        </p:blipFill>
-        <p:spPr>
-          <a:xfrm>
-            <a:off x="6746240" y="1596898"/>
-            <a:ext cx="5074920" cy="2951308"/>
-          </a:xfrm>
-          <a:prstGeom prst="rect">
-            <a:avLst/>
-          </a:prstGeom>
-        </p:spPr>
-      </p:pic>
     </p:spTree>
   </p:cSld>
   <p:clrMapOvr>

</xml_diff>

<commit_message>
Update FlowRanking diagnostics and results
</commit_message>
<xml_diff>
--- a/assets/flow_ranking_slides.pptx
+++ b/assets/flow_ranking_slides.pptx
@@ -3334,7 +3334,7 @@
                 </a:solidFill>
                 <a:latin typeface="Aptos"/>
               </a:rPr>
-              <a:t>Final Top-10 comparison: FlowRanking matches the strongest ranking baseline.</a:t>
+              <a:t>Final comparison: FlowRanking exceeds the strongest baselines across all tasks.</a:t>
             </a:r>
             <a:endParaRPr sz="1100" b="0">
               <a:solidFill>
@@ -7963,7 +7963,7 @@
                 </a:solidFill>
                 <a:latin typeface="Aptos"/>
               </a:rPr>
-              <a:t>Training curves are kept only as optimization context for the neural baseline.</a:t>
+              <a:t>The diagnostic curves show high-confidence precision/coverage behavior and rating-error tolerance beyond the headline bar metrics.</a:t>
             </a:r>
             <a:endParaRPr sz="1100" b="0">
               <a:solidFill>

</xml_diff>